<commit_message>
Add iconcard KiCad schematic, PCB layout, and custom footprints
Co-Authored-By: Claude Opus 4.6 <noreply@anthropic.com>
</commit_message>
<xml_diff>
--- a/design.pptx
+++ b/design.pptx
@@ -8,6 +8,7 @@
     <p:sldId id="256" r:id="rId2"/>
     <p:sldId id="257" r:id="rId3"/>
     <p:sldId id="258" r:id="rId4"/>
+    <p:sldId id="259" r:id="rId5"/>
   </p:sldIdLst>
   <p:sldSz cx="12192000" cy="6858000"/>
   <p:notesSz cx="6858000" cy="9144000"/>
@@ -261,7 +262,7 @@
           <a:p>
             <a:fld id="{9D438905-DEFC-F846-8BB0-00C4187231C1}" type="datetimeFigureOut">
               <a:rPr kumimoji="1" lang="ja-JP" altLang="en-US" smtClean="0"/>
-              <a:t>2026/2/7</a:t>
+              <a:t>2026/2/14</a:t>
             </a:fld>
             <a:endParaRPr kumimoji="1" lang="ja-JP" altLang="en-US"/>
           </a:p>
@@ -491,7 +492,7 @@
           <a:p>
             <a:fld id="{9D438905-DEFC-F846-8BB0-00C4187231C1}" type="datetimeFigureOut">
               <a:rPr kumimoji="1" lang="ja-JP" altLang="en-US" smtClean="0"/>
-              <a:t>2026/2/7</a:t>
+              <a:t>2026/2/14</a:t>
             </a:fld>
             <a:endParaRPr kumimoji="1" lang="ja-JP" altLang="en-US"/>
           </a:p>
@@ -731,7 +732,7 @@
           <a:p>
             <a:fld id="{9D438905-DEFC-F846-8BB0-00C4187231C1}" type="datetimeFigureOut">
               <a:rPr kumimoji="1" lang="ja-JP" altLang="en-US" smtClean="0"/>
-              <a:t>2026/2/7</a:t>
+              <a:t>2026/2/14</a:t>
             </a:fld>
             <a:endParaRPr kumimoji="1" lang="ja-JP" altLang="en-US"/>
           </a:p>
@@ -961,7 +962,7 @@
           <a:p>
             <a:fld id="{9D438905-DEFC-F846-8BB0-00C4187231C1}" type="datetimeFigureOut">
               <a:rPr kumimoji="1" lang="ja-JP" altLang="en-US" smtClean="0"/>
-              <a:t>2026/2/7</a:t>
+              <a:t>2026/2/14</a:t>
             </a:fld>
             <a:endParaRPr kumimoji="1" lang="ja-JP" altLang="en-US"/>
           </a:p>
@@ -1236,7 +1237,7 @@
           <a:p>
             <a:fld id="{9D438905-DEFC-F846-8BB0-00C4187231C1}" type="datetimeFigureOut">
               <a:rPr kumimoji="1" lang="ja-JP" altLang="en-US" smtClean="0"/>
-              <a:t>2026/2/7</a:t>
+              <a:t>2026/2/14</a:t>
             </a:fld>
             <a:endParaRPr kumimoji="1" lang="ja-JP" altLang="en-US"/>
           </a:p>
@@ -1565,7 +1566,7 @@
           <a:p>
             <a:fld id="{9D438905-DEFC-F846-8BB0-00C4187231C1}" type="datetimeFigureOut">
               <a:rPr kumimoji="1" lang="ja-JP" altLang="en-US" smtClean="0"/>
-              <a:t>2026/2/7</a:t>
+              <a:t>2026/2/14</a:t>
             </a:fld>
             <a:endParaRPr kumimoji="1" lang="ja-JP" altLang="en-US"/>
           </a:p>
@@ -2041,7 +2042,7 @@
           <a:p>
             <a:fld id="{9D438905-DEFC-F846-8BB0-00C4187231C1}" type="datetimeFigureOut">
               <a:rPr kumimoji="1" lang="ja-JP" altLang="en-US" smtClean="0"/>
-              <a:t>2026/2/7</a:t>
+              <a:t>2026/2/14</a:t>
             </a:fld>
             <a:endParaRPr kumimoji="1" lang="ja-JP" altLang="en-US"/>
           </a:p>
@@ -2182,7 +2183,7 @@
           <a:p>
             <a:fld id="{9D438905-DEFC-F846-8BB0-00C4187231C1}" type="datetimeFigureOut">
               <a:rPr kumimoji="1" lang="ja-JP" altLang="en-US" smtClean="0"/>
-              <a:t>2026/2/7</a:t>
+              <a:t>2026/2/14</a:t>
             </a:fld>
             <a:endParaRPr kumimoji="1" lang="ja-JP" altLang="en-US"/>
           </a:p>
@@ -2295,7 +2296,7 @@
           <a:p>
             <a:fld id="{9D438905-DEFC-F846-8BB0-00C4187231C1}" type="datetimeFigureOut">
               <a:rPr kumimoji="1" lang="ja-JP" altLang="en-US" smtClean="0"/>
-              <a:t>2026/2/7</a:t>
+              <a:t>2026/2/14</a:t>
             </a:fld>
             <a:endParaRPr kumimoji="1" lang="ja-JP" altLang="en-US"/>
           </a:p>
@@ -2638,7 +2639,7 @@
           <a:p>
             <a:fld id="{9D438905-DEFC-F846-8BB0-00C4187231C1}" type="datetimeFigureOut">
               <a:rPr kumimoji="1" lang="ja-JP" altLang="en-US" smtClean="0"/>
-              <a:t>2026/2/7</a:t>
+              <a:t>2026/2/14</a:t>
             </a:fld>
             <a:endParaRPr kumimoji="1" lang="ja-JP" altLang="en-US"/>
           </a:p>
@@ -2926,7 +2927,7 @@
           <a:p>
             <a:fld id="{9D438905-DEFC-F846-8BB0-00C4187231C1}" type="datetimeFigureOut">
               <a:rPr kumimoji="1" lang="ja-JP" altLang="en-US" smtClean="0"/>
-              <a:t>2026/2/7</a:t>
+              <a:t>2026/2/14</a:t>
             </a:fld>
             <a:endParaRPr kumimoji="1" lang="ja-JP" altLang="en-US"/>
           </a:p>
@@ -3199,7 +3200,7 @@
           <a:p>
             <a:fld id="{9D438905-DEFC-F846-8BB0-00C4187231C1}" type="datetimeFigureOut">
               <a:rPr kumimoji="1" lang="ja-JP" altLang="en-US" smtClean="0"/>
-              <a:t>2026/2/7</a:t>
+              <a:t>2026/2/14</a:t>
             </a:fld>
             <a:endParaRPr kumimoji="1" lang="ja-JP" altLang="en-US"/>
           </a:p>
@@ -13791,6 +13792,3404 @@
 </p:sld>
 </file>
 
+<file path=ppt/slides/slide4.xml><?xml version="1.0" encoding="utf-8"?>
+<p:sld xmlns:a="http://schemas.openxmlformats.org/drawingml/2006/main" xmlns:r="http://schemas.openxmlformats.org/officeDocument/2006/relationships" xmlns:p="http://schemas.openxmlformats.org/presentationml/2006/main">
+  <p:cSld>
+    <p:spTree>
+      <p:nvGrpSpPr>
+        <p:cNvPr id="1" name="">
+          <a:extLst>
+            <a:ext uri="{FF2B5EF4-FFF2-40B4-BE49-F238E27FC236}">
+              <a16:creationId xmlns:a16="http://schemas.microsoft.com/office/drawing/2014/main" id="{7A15E9A9-23A6-FBB0-4664-96512233184D}"/>
+            </a:ext>
+          </a:extLst>
+        </p:cNvPr>
+        <p:cNvGrpSpPr/>
+        <p:nvPr/>
+      </p:nvGrpSpPr>
+      <p:grpSpPr>
+        <a:xfrm>
+          <a:off x="0" y="0"/>
+          <a:ext cx="0" cy="0"/>
+          <a:chOff x="0" y="0"/>
+          <a:chExt cx="0" cy="0"/>
+        </a:xfrm>
+      </p:grpSpPr>
+      <p:grpSp>
+        <p:nvGrpSpPr>
+          <p:cNvPr id="8" name="グループ化 7">
+            <a:extLst>
+              <a:ext uri="{FF2B5EF4-FFF2-40B4-BE49-F238E27FC236}">
+                <a16:creationId xmlns:a16="http://schemas.microsoft.com/office/drawing/2014/main" id="{13A7ED4E-DA93-68DA-E562-432A708A2DC5}"/>
+              </a:ext>
+            </a:extLst>
+          </p:cNvPr>
+          <p:cNvGrpSpPr/>
+          <p:nvPr/>
+        </p:nvGrpSpPr>
+        <p:grpSpPr>
+          <a:xfrm rot="16200000">
+            <a:off x="5240185" y="1047314"/>
+            <a:ext cx="3068080" cy="2117122"/>
+            <a:chOff x="4788081" y="486906"/>
+            <a:chExt cx="3068080" cy="2117122"/>
+          </a:xfrm>
+        </p:grpSpPr>
+        <p:pic>
+          <p:nvPicPr>
+            <p:cNvPr id="9" name="グラフィックス 8">
+              <a:extLst>
+                <a:ext uri="{FF2B5EF4-FFF2-40B4-BE49-F238E27FC236}">
+                  <a16:creationId xmlns:a16="http://schemas.microsoft.com/office/drawing/2014/main" id="{A4A55B3A-DFC8-A93A-A0FC-9B3E9A442F31}"/>
+                </a:ext>
+              </a:extLst>
+            </p:cNvPr>
+            <p:cNvPicPr>
+              <a:picLocks noChangeAspect="1"/>
+            </p:cNvPicPr>
+            <p:nvPr/>
+          </p:nvPicPr>
+          <p:blipFill>
+            <a:blip r:embed="rId2">
+              <a:extLst>
+                <a:ext uri="{96DAC541-7B7A-43D3-8B79-37D633B846F1}">
+                  <asvg:svgBlip xmlns:asvg="http://schemas.microsoft.com/office/drawing/2016/SVG/main" r:embed="rId3"/>
+                </a:ext>
+              </a:extLst>
+            </a:blip>
+            <a:srcRect l="23290" t="6158" r="61766"/>
+            <a:stretch/>
+          </p:blipFill>
+          <p:spPr>
+            <a:xfrm rot="16200000">
+              <a:off x="5263560" y="11427"/>
+              <a:ext cx="2117122" cy="3068080"/>
+            </a:xfrm>
+            <a:prstGeom prst="rect">
+              <a:avLst/>
+            </a:prstGeom>
+          </p:spPr>
+        </p:pic>
+        <p:sp>
+          <p:nvSpPr>
+            <p:cNvPr id="292" name="円/楕円 291">
+              <a:extLst>
+                <a:ext uri="{FF2B5EF4-FFF2-40B4-BE49-F238E27FC236}">
+                  <a16:creationId xmlns:a16="http://schemas.microsoft.com/office/drawing/2014/main" id="{4DBFD3E1-DA9E-ED55-A4DA-3A1C383C4FDB}"/>
+                </a:ext>
+              </a:extLst>
+            </p:cNvPr>
+            <p:cNvSpPr/>
+            <p:nvPr/>
+          </p:nvSpPr>
+          <p:spPr>
+            <a:xfrm rot="10800000">
+              <a:off x="6745011" y="690242"/>
+              <a:ext cx="168339" cy="174795"/>
+            </a:xfrm>
+            <a:prstGeom prst="ellipse">
+              <a:avLst/>
+            </a:prstGeom>
+            <a:solidFill>
+              <a:schemeClr val="bg1"/>
+            </a:solidFill>
+            <a:ln>
+              <a:solidFill>
+                <a:schemeClr val="tx1"/>
+              </a:solidFill>
+            </a:ln>
+          </p:spPr>
+          <p:style>
+            <a:lnRef idx="2">
+              <a:schemeClr val="accent1">
+                <a:shade val="15000"/>
+              </a:schemeClr>
+            </a:lnRef>
+            <a:fillRef idx="1">
+              <a:schemeClr val="accent1"/>
+            </a:fillRef>
+            <a:effectRef idx="0">
+              <a:schemeClr val="accent1"/>
+            </a:effectRef>
+            <a:fontRef idx="minor">
+              <a:schemeClr val="lt1"/>
+            </a:fontRef>
+          </p:style>
+          <p:txBody>
+            <a:bodyPr rtlCol="0" anchor="ctr"/>
+            <a:lstStyle/>
+            <a:p>
+              <a:pPr algn="ctr"/>
+              <a:endParaRPr kumimoji="1" lang="ja-JP" altLang="en-US"/>
+            </a:p>
+          </p:txBody>
+        </p:sp>
+        <p:sp>
+          <p:nvSpPr>
+            <p:cNvPr id="301" name="円/楕円 300">
+              <a:extLst>
+                <a:ext uri="{FF2B5EF4-FFF2-40B4-BE49-F238E27FC236}">
+                  <a16:creationId xmlns:a16="http://schemas.microsoft.com/office/drawing/2014/main" id="{E43C8210-F274-546C-DF76-6CBF7B812C97}"/>
+                </a:ext>
+              </a:extLst>
+            </p:cNvPr>
+            <p:cNvSpPr/>
+            <p:nvPr/>
+          </p:nvSpPr>
+          <p:spPr>
+            <a:xfrm rot="10800000">
+              <a:off x="7655564" y="692760"/>
+              <a:ext cx="168339" cy="174795"/>
+            </a:xfrm>
+            <a:prstGeom prst="ellipse">
+              <a:avLst/>
+            </a:prstGeom>
+            <a:solidFill>
+              <a:schemeClr val="bg1"/>
+            </a:solidFill>
+            <a:ln>
+              <a:solidFill>
+                <a:schemeClr val="tx1"/>
+              </a:solidFill>
+            </a:ln>
+          </p:spPr>
+          <p:style>
+            <a:lnRef idx="2">
+              <a:schemeClr val="accent1">
+                <a:shade val="15000"/>
+              </a:schemeClr>
+            </a:lnRef>
+            <a:fillRef idx="1">
+              <a:schemeClr val="accent1"/>
+            </a:fillRef>
+            <a:effectRef idx="0">
+              <a:schemeClr val="accent1"/>
+            </a:effectRef>
+            <a:fontRef idx="minor">
+              <a:schemeClr val="lt1"/>
+            </a:fontRef>
+          </p:style>
+          <p:txBody>
+            <a:bodyPr rtlCol="0" anchor="ctr"/>
+            <a:lstStyle/>
+            <a:p>
+              <a:pPr algn="ctr"/>
+              <a:endParaRPr kumimoji="1" lang="ja-JP" altLang="en-US"/>
+            </a:p>
+          </p:txBody>
+        </p:sp>
+        <p:sp>
+          <p:nvSpPr>
+            <p:cNvPr id="17" name="円/楕円 16">
+              <a:extLst>
+                <a:ext uri="{FF2B5EF4-FFF2-40B4-BE49-F238E27FC236}">
+                  <a16:creationId xmlns:a16="http://schemas.microsoft.com/office/drawing/2014/main" id="{B7D46076-28FE-2E32-2B17-E4F40C773AB3}"/>
+                </a:ext>
+              </a:extLst>
+            </p:cNvPr>
+            <p:cNvSpPr/>
+            <p:nvPr/>
+          </p:nvSpPr>
+          <p:spPr>
+            <a:xfrm rot="10800000">
+              <a:off x="4944033" y="684844"/>
+              <a:ext cx="168339" cy="174795"/>
+            </a:xfrm>
+            <a:prstGeom prst="ellipse">
+              <a:avLst/>
+            </a:prstGeom>
+            <a:solidFill>
+              <a:schemeClr val="bg1"/>
+            </a:solidFill>
+            <a:ln>
+              <a:solidFill>
+                <a:schemeClr val="tx1"/>
+              </a:solidFill>
+            </a:ln>
+          </p:spPr>
+          <p:style>
+            <a:lnRef idx="2">
+              <a:schemeClr val="accent1">
+                <a:shade val="15000"/>
+              </a:schemeClr>
+            </a:lnRef>
+            <a:fillRef idx="1">
+              <a:schemeClr val="accent1"/>
+            </a:fillRef>
+            <a:effectRef idx="0">
+              <a:schemeClr val="accent1"/>
+            </a:effectRef>
+            <a:fontRef idx="minor">
+              <a:schemeClr val="lt1"/>
+            </a:fontRef>
+          </p:style>
+          <p:txBody>
+            <a:bodyPr rtlCol="0" anchor="ctr"/>
+            <a:lstStyle/>
+            <a:p>
+              <a:pPr algn="ctr"/>
+              <a:endParaRPr kumimoji="1" lang="ja-JP" altLang="en-US"/>
+            </a:p>
+          </p:txBody>
+        </p:sp>
+        <p:sp>
+          <p:nvSpPr>
+            <p:cNvPr id="21" name="円/楕円 20">
+              <a:extLst>
+                <a:ext uri="{FF2B5EF4-FFF2-40B4-BE49-F238E27FC236}">
+                  <a16:creationId xmlns:a16="http://schemas.microsoft.com/office/drawing/2014/main" id="{74E1ADB9-AF62-75C7-1AF9-BBB7C55E2A8C}"/>
+                </a:ext>
+              </a:extLst>
+            </p:cNvPr>
+            <p:cNvSpPr/>
+            <p:nvPr/>
+          </p:nvSpPr>
+          <p:spPr>
+            <a:xfrm rot="10800000">
+              <a:off x="4930176" y="2194990"/>
+              <a:ext cx="168339" cy="174795"/>
+            </a:xfrm>
+            <a:prstGeom prst="ellipse">
+              <a:avLst/>
+            </a:prstGeom>
+            <a:solidFill>
+              <a:schemeClr val="bg1"/>
+            </a:solidFill>
+            <a:ln>
+              <a:solidFill>
+                <a:schemeClr val="tx1"/>
+              </a:solidFill>
+            </a:ln>
+          </p:spPr>
+          <p:style>
+            <a:lnRef idx="2">
+              <a:schemeClr val="accent1">
+                <a:shade val="15000"/>
+              </a:schemeClr>
+            </a:lnRef>
+            <a:fillRef idx="1">
+              <a:schemeClr val="accent1"/>
+            </a:fillRef>
+            <a:effectRef idx="0">
+              <a:schemeClr val="accent1"/>
+            </a:effectRef>
+            <a:fontRef idx="minor">
+              <a:schemeClr val="lt1"/>
+            </a:fontRef>
+          </p:style>
+          <p:txBody>
+            <a:bodyPr rtlCol="0" anchor="ctr"/>
+            <a:lstStyle/>
+            <a:p>
+              <a:pPr algn="ctr"/>
+              <a:endParaRPr kumimoji="1" lang="ja-JP" altLang="en-US"/>
+            </a:p>
+          </p:txBody>
+        </p:sp>
+        <p:sp>
+          <p:nvSpPr>
+            <p:cNvPr id="53" name="円/楕円 52">
+              <a:extLst>
+                <a:ext uri="{FF2B5EF4-FFF2-40B4-BE49-F238E27FC236}">
+                  <a16:creationId xmlns:a16="http://schemas.microsoft.com/office/drawing/2014/main" id="{DF2EEB4C-9493-CEA9-7BE5-571CDF8E0055}"/>
+                </a:ext>
+              </a:extLst>
+            </p:cNvPr>
+            <p:cNvSpPr/>
+            <p:nvPr/>
+          </p:nvSpPr>
+          <p:spPr>
+            <a:xfrm rot="10800000">
+              <a:off x="5830721" y="2196969"/>
+              <a:ext cx="168339" cy="174795"/>
+            </a:xfrm>
+            <a:prstGeom prst="ellipse">
+              <a:avLst/>
+            </a:prstGeom>
+            <a:solidFill>
+              <a:schemeClr val="bg1"/>
+            </a:solidFill>
+            <a:ln>
+              <a:solidFill>
+                <a:schemeClr val="tx1"/>
+              </a:solidFill>
+            </a:ln>
+          </p:spPr>
+          <p:style>
+            <a:lnRef idx="2">
+              <a:schemeClr val="accent1">
+                <a:shade val="15000"/>
+              </a:schemeClr>
+            </a:lnRef>
+            <a:fillRef idx="1">
+              <a:schemeClr val="accent1"/>
+            </a:fillRef>
+            <a:effectRef idx="0">
+              <a:schemeClr val="accent1"/>
+            </a:effectRef>
+            <a:fontRef idx="minor">
+              <a:schemeClr val="lt1"/>
+            </a:fontRef>
+          </p:style>
+          <p:txBody>
+            <a:bodyPr rtlCol="0" anchor="ctr"/>
+            <a:lstStyle/>
+            <a:p>
+              <a:pPr algn="ctr"/>
+              <a:endParaRPr kumimoji="1" lang="ja-JP" altLang="en-US"/>
+            </a:p>
+          </p:txBody>
+        </p:sp>
+        <p:sp>
+          <p:nvSpPr>
+            <p:cNvPr id="70" name="円/楕円 69">
+              <a:extLst>
+                <a:ext uri="{FF2B5EF4-FFF2-40B4-BE49-F238E27FC236}">
+                  <a16:creationId xmlns:a16="http://schemas.microsoft.com/office/drawing/2014/main" id="{57DF0929-F8E0-7315-DAD9-B08042DBEEE5}"/>
+                </a:ext>
+              </a:extLst>
+            </p:cNvPr>
+            <p:cNvSpPr/>
+            <p:nvPr/>
+          </p:nvSpPr>
+          <p:spPr>
+            <a:xfrm rot="10800000">
+              <a:off x="6147400" y="2189049"/>
+              <a:ext cx="168339" cy="174795"/>
+            </a:xfrm>
+            <a:prstGeom prst="ellipse">
+              <a:avLst/>
+            </a:prstGeom>
+            <a:solidFill>
+              <a:schemeClr val="bg1"/>
+            </a:solidFill>
+            <a:ln>
+              <a:solidFill>
+                <a:schemeClr val="tx1"/>
+              </a:solidFill>
+            </a:ln>
+          </p:spPr>
+          <p:style>
+            <a:lnRef idx="2">
+              <a:schemeClr val="accent1">
+                <a:shade val="15000"/>
+              </a:schemeClr>
+            </a:lnRef>
+            <a:fillRef idx="1">
+              <a:schemeClr val="accent1"/>
+            </a:fillRef>
+            <a:effectRef idx="0">
+              <a:schemeClr val="accent1"/>
+            </a:effectRef>
+            <a:fontRef idx="minor">
+              <a:schemeClr val="lt1"/>
+            </a:fontRef>
+          </p:style>
+          <p:txBody>
+            <a:bodyPr rtlCol="0" anchor="ctr"/>
+            <a:lstStyle/>
+            <a:p>
+              <a:pPr algn="ctr"/>
+              <a:endParaRPr kumimoji="1" lang="ja-JP" altLang="en-US"/>
+            </a:p>
+          </p:txBody>
+        </p:sp>
+        <p:sp>
+          <p:nvSpPr>
+            <p:cNvPr id="80" name="円/楕円 79">
+              <a:extLst>
+                <a:ext uri="{FF2B5EF4-FFF2-40B4-BE49-F238E27FC236}">
+                  <a16:creationId xmlns:a16="http://schemas.microsoft.com/office/drawing/2014/main" id="{2A7AEA1A-C106-EC73-4BCA-AFA03023562F}"/>
+                </a:ext>
+              </a:extLst>
+            </p:cNvPr>
+            <p:cNvSpPr/>
+            <p:nvPr/>
+          </p:nvSpPr>
+          <p:spPr>
+            <a:xfrm rot="10800000">
+              <a:off x="6751059" y="2191027"/>
+              <a:ext cx="168339" cy="174795"/>
+            </a:xfrm>
+            <a:prstGeom prst="ellipse">
+              <a:avLst/>
+            </a:prstGeom>
+            <a:solidFill>
+              <a:schemeClr val="bg1"/>
+            </a:solidFill>
+            <a:ln>
+              <a:solidFill>
+                <a:schemeClr val="tx1"/>
+              </a:solidFill>
+            </a:ln>
+          </p:spPr>
+          <p:style>
+            <a:lnRef idx="2">
+              <a:schemeClr val="accent1">
+                <a:shade val="15000"/>
+              </a:schemeClr>
+            </a:lnRef>
+            <a:fillRef idx="1">
+              <a:schemeClr val="accent1"/>
+            </a:fillRef>
+            <a:effectRef idx="0">
+              <a:schemeClr val="accent1"/>
+            </a:effectRef>
+            <a:fontRef idx="minor">
+              <a:schemeClr val="lt1"/>
+            </a:fontRef>
+          </p:style>
+          <p:txBody>
+            <a:bodyPr rtlCol="0" anchor="ctr"/>
+            <a:lstStyle/>
+            <a:p>
+              <a:pPr algn="ctr"/>
+              <a:endParaRPr kumimoji="1" lang="ja-JP" altLang="en-US"/>
+            </a:p>
+          </p:txBody>
+        </p:sp>
+        <p:sp>
+          <p:nvSpPr>
+            <p:cNvPr id="95" name="円/楕円 94">
+              <a:extLst>
+                <a:ext uri="{FF2B5EF4-FFF2-40B4-BE49-F238E27FC236}">
+                  <a16:creationId xmlns:a16="http://schemas.microsoft.com/office/drawing/2014/main" id="{58BA2874-D6DE-AAFB-6FE4-CDE982F75C71}"/>
+                </a:ext>
+              </a:extLst>
+            </p:cNvPr>
+            <p:cNvSpPr/>
+            <p:nvPr/>
+          </p:nvSpPr>
+          <p:spPr>
+            <a:xfrm rot="10800000">
+              <a:off x="7045962" y="2193006"/>
+              <a:ext cx="168339" cy="174795"/>
+            </a:xfrm>
+            <a:prstGeom prst="ellipse">
+              <a:avLst/>
+            </a:prstGeom>
+            <a:solidFill>
+              <a:schemeClr val="bg1"/>
+            </a:solidFill>
+            <a:ln>
+              <a:solidFill>
+                <a:schemeClr val="tx1"/>
+              </a:solidFill>
+            </a:ln>
+          </p:spPr>
+          <p:style>
+            <a:lnRef idx="2">
+              <a:schemeClr val="accent1">
+                <a:shade val="15000"/>
+              </a:schemeClr>
+            </a:lnRef>
+            <a:fillRef idx="1">
+              <a:schemeClr val="accent1"/>
+            </a:fillRef>
+            <a:effectRef idx="0">
+              <a:schemeClr val="accent1"/>
+            </a:effectRef>
+            <a:fontRef idx="minor">
+              <a:schemeClr val="lt1"/>
+            </a:fontRef>
+          </p:style>
+          <p:txBody>
+            <a:bodyPr rtlCol="0" anchor="ctr"/>
+            <a:lstStyle/>
+            <a:p>
+              <a:pPr algn="ctr"/>
+              <a:endParaRPr kumimoji="1" lang="ja-JP" altLang="en-US"/>
+            </a:p>
+          </p:txBody>
+        </p:sp>
+        <p:sp>
+          <p:nvSpPr>
+            <p:cNvPr id="101" name="円/楕円 100">
+              <a:extLst>
+                <a:ext uri="{FF2B5EF4-FFF2-40B4-BE49-F238E27FC236}">
+                  <a16:creationId xmlns:a16="http://schemas.microsoft.com/office/drawing/2014/main" id="{566BDA0B-D74D-0079-7B19-7E18395C3992}"/>
+                </a:ext>
+              </a:extLst>
+            </p:cNvPr>
+            <p:cNvSpPr/>
+            <p:nvPr/>
+          </p:nvSpPr>
+          <p:spPr>
+            <a:xfrm rot="10800000">
+              <a:off x="7348673" y="680347"/>
+              <a:ext cx="168339" cy="174795"/>
+            </a:xfrm>
+            <a:prstGeom prst="ellipse">
+              <a:avLst/>
+            </a:prstGeom>
+            <a:solidFill>
+              <a:schemeClr val="bg1"/>
+            </a:solidFill>
+            <a:ln>
+              <a:solidFill>
+                <a:schemeClr val="tx1"/>
+              </a:solidFill>
+            </a:ln>
+          </p:spPr>
+          <p:style>
+            <a:lnRef idx="2">
+              <a:schemeClr val="accent1">
+                <a:shade val="15000"/>
+              </a:schemeClr>
+            </a:lnRef>
+            <a:fillRef idx="1">
+              <a:schemeClr val="accent1"/>
+            </a:fillRef>
+            <a:effectRef idx="0">
+              <a:schemeClr val="accent1"/>
+            </a:effectRef>
+            <a:fontRef idx="minor">
+              <a:schemeClr val="lt1"/>
+            </a:fontRef>
+          </p:style>
+          <p:txBody>
+            <a:bodyPr rtlCol="0" anchor="ctr"/>
+            <a:lstStyle/>
+            <a:p>
+              <a:pPr algn="ctr"/>
+              <a:endParaRPr kumimoji="1" lang="ja-JP" altLang="en-US"/>
+            </a:p>
+          </p:txBody>
+        </p:sp>
+        <p:sp>
+          <p:nvSpPr>
+            <p:cNvPr id="74" name="円/楕円 73">
+              <a:extLst>
+                <a:ext uri="{FF2B5EF4-FFF2-40B4-BE49-F238E27FC236}">
+                  <a16:creationId xmlns:a16="http://schemas.microsoft.com/office/drawing/2014/main" id="{9C87612A-5A00-C2CA-199A-DBFC287D9425}"/>
+                </a:ext>
+              </a:extLst>
+            </p:cNvPr>
+            <p:cNvSpPr/>
+            <p:nvPr/>
+          </p:nvSpPr>
+          <p:spPr>
+            <a:xfrm rot="10800000">
+              <a:off x="7340865" y="2167276"/>
+              <a:ext cx="168339" cy="174795"/>
+            </a:xfrm>
+            <a:prstGeom prst="ellipse">
+              <a:avLst/>
+            </a:prstGeom>
+            <a:solidFill>
+              <a:schemeClr val="bg1"/>
+            </a:solidFill>
+            <a:ln>
+              <a:solidFill>
+                <a:schemeClr val="tx1"/>
+              </a:solidFill>
+            </a:ln>
+          </p:spPr>
+          <p:style>
+            <a:lnRef idx="2">
+              <a:schemeClr val="accent1">
+                <a:shade val="15000"/>
+              </a:schemeClr>
+            </a:lnRef>
+            <a:fillRef idx="1">
+              <a:schemeClr val="accent1"/>
+            </a:fillRef>
+            <a:effectRef idx="0">
+              <a:schemeClr val="accent1"/>
+            </a:effectRef>
+            <a:fontRef idx="minor">
+              <a:schemeClr val="lt1"/>
+            </a:fontRef>
+          </p:style>
+          <p:txBody>
+            <a:bodyPr rtlCol="0" anchor="ctr"/>
+            <a:lstStyle/>
+            <a:p>
+              <a:pPr algn="ctr"/>
+              <a:endParaRPr kumimoji="1" lang="ja-JP" altLang="en-US"/>
+            </a:p>
+          </p:txBody>
+        </p:sp>
+      </p:grpSp>
+      <p:cxnSp>
+        <p:nvCxnSpPr>
+          <p:cNvPr id="109" name="カギ線コネクタ 108">
+            <a:extLst>
+              <a:ext uri="{FF2B5EF4-FFF2-40B4-BE49-F238E27FC236}">
+                <a16:creationId xmlns:a16="http://schemas.microsoft.com/office/drawing/2014/main" id="{6F20B225-D03F-966E-7ABC-52E8A997045F}"/>
+              </a:ext>
+            </a:extLst>
+          </p:cNvPr>
+          <p:cNvCxnSpPr>
+            <a:cxnSpLocks/>
+            <a:stCxn id="292" idx="0"/>
+            <a:endCxn id="22" idx="4"/>
+          </p:cNvCxnSpPr>
+          <p:nvPr/>
+        </p:nvCxnSpPr>
+        <p:spPr>
+          <a:xfrm flipV="1">
+            <a:off x="6093795" y="588813"/>
+            <a:ext cx="600006" cy="1010003"/>
+          </a:xfrm>
+          <a:prstGeom prst="bentConnector2">
+            <a:avLst/>
+          </a:prstGeom>
+          <a:ln w="63500">
+            <a:solidFill>
+              <a:schemeClr val="tx1">
+                <a:lumMod val="50000"/>
+                <a:lumOff val="50000"/>
+              </a:schemeClr>
+            </a:solidFill>
+            <a:prstDash val="sysDot"/>
+          </a:ln>
+        </p:spPr>
+        <p:style>
+          <a:lnRef idx="2">
+            <a:schemeClr val="accent1"/>
+          </a:lnRef>
+          <a:fillRef idx="0">
+            <a:schemeClr val="accent1"/>
+          </a:fillRef>
+          <a:effectRef idx="1">
+            <a:schemeClr val="accent1"/>
+          </a:effectRef>
+          <a:fontRef idx="minor">
+            <a:schemeClr val="tx1"/>
+          </a:fontRef>
+        </p:style>
+      </p:cxnSp>
+      <p:grpSp>
+        <p:nvGrpSpPr>
+          <p:cNvPr id="2" name="グループ化 1">
+            <a:extLst>
+              <a:ext uri="{FF2B5EF4-FFF2-40B4-BE49-F238E27FC236}">
+                <a16:creationId xmlns:a16="http://schemas.microsoft.com/office/drawing/2014/main" id="{F3811D32-3DAC-1202-7D2A-0862888F0B4B}"/>
+              </a:ext>
+            </a:extLst>
+          </p:cNvPr>
+          <p:cNvGrpSpPr/>
+          <p:nvPr/>
+        </p:nvGrpSpPr>
+        <p:grpSpPr>
+          <a:xfrm rot="10800000">
+            <a:off x="3320481" y="1642655"/>
+            <a:ext cx="2117123" cy="2527341"/>
+            <a:chOff x="4742379" y="2860296"/>
+            <a:chExt cx="2117123" cy="2527341"/>
+          </a:xfrm>
+        </p:grpSpPr>
+        <p:sp>
+          <p:nvSpPr>
+            <p:cNvPr id="227" name="左中かっこ 226">
+              <a:extLst>
+                <a:ext uri="{FF2B5EF4-FFF2-40B4-BE49-F238E27FC236}">
+                  <a16:creationId xmlns:a16="http://schemas.microsoft.com/office/drawing/2014/main" id="{9F359065-A89F-88BD-4EB9-BBD923C96C37}"/>
+                </a:ext>
+              </a:extLst>
+            </p:cNvPr>
+            <p:cNvSpPr/>
+            <p:nvPr/>
+          </p:nvSpPr>
+          <p:spPr>
+            <a:xfrm rot="16200000">
+              <a:off x="5248424" y="4793376"/>
+              <a:ext cx="282897" cy="905626"/>
+            </a:xfrm>
+            <a:prstGeom prst="leftBrace">
+              <a:avLst/>
+            </a:prstGeom>
+          </p:spPr>
+          <p:style>
+            <a:lnRef idx="2">
+              <a:schemeClr val="accent1"/>
+            </a:lnRef>
+            <a:fillRef idx="0">
+              <a:schemeClr val="accent1"/>
+            </a:fillRef>
+            <a:effectRef idx="1">
+              <a:schemeClr val="accent1"/>
+            </a:effectRef>
+            <a:fontRef idx="minor">
+              <a:schemeClr val="tx1"/>
+            </a:fontRef>
+          </p:style>
+          <p:txBody>
+            <a:bodyPr rtlCol="0" anchor="ctr"/>
+            <a:lstStyle/>
+            <a:p>
+              <a:pPr algn="ctr"/>
+              <a:endParaRPr kumimoji="1" lang="ja-JP" altLang="en-US"/>
+            </a:p>
+          </p:txBody>
+        </p:sp>
+        <p:pic>
+          <p:nvPicPr>
+            <p:cNvPr id="7" name="図 6" descr="ダイアグラム, 概略図&#10;&#10;AI によって生成されたコンテンツは間違っている可能性があります。">
+              <a:extLst>
+                <a:ext uri="{FF2B5EF4-FFF2-40B4-BE49-F238E27FC236}">
+                  <a16:creationId xmlns:a16="http://schemas.microsoft.com/office/drawing/2014/main" id="{FA6AFCEA-88F1-9C9D-6D37-F90EA4B34AE7}"/>
+                </a:ext>
+              </a:extLst>
+            </p:cNvPr>
+            <p:cNvPicPr>
+              <a:picLocks noChangeAspect="1"/>
+            </p:cNvPicPr>
+            <p:nvPr/>
+          </p:nvPicPr>
+          <p:blipFill>
+            <a:blip r:embed="rId4"/>
+            <a:stretch>
+              <a:fillRect/>
+            </a:stretch>
+          </p:blipFill>
+          <p:spPr>
+            <a:xfrm rot="10800000">
+              <a:off x="4742379" y="2860296"/>
+              <a:ext cx="2117123" cy="2387558"/>
+            </a:xfrm>
+            <a:prstGeom prst="rect">
+              <a:avLst/>
+            </a:prstGeom>
+          </p:spPr>
+        </p:pic>
+        <p:cxnSp>
+          <p:nvCxnSpPr>
+            <p:cNvPr id="26" name="カギ線コネクタ 25">
+              <a:extLst>
+                <a:ext uri="{FF2B5EF4-FFF2-40B4-BE49-F238E27FC236}">
+                  <a16:creationId xmlns:a16="http://schemas.microsoft.com/office/drawing/2014/main" id="{52F70EC6-638A-C2A1-6A83-F579868433C6}"/>
+                </a:ext>
+              </a:extLst>
+            </p:cNvPr>
+            <p:cNvCxnSpPr>
+              <a:cxnSpLocks/>
+              <a:endCxn id="36" idx="2"/>
+            </p:cNvCxnSpPr>
+            <p:nvPr/>
+          </p:nvCxnSpPr>
+          <p:spPr>
+            <a:xfrm rot="10800000" flipV="1">
+              <a:off x="5243000" y="3617666"/>
+              <a:ext cx="858630" cy="634043"/>
+            </a:xfrm>
+            <a:prstGeom prst="bentConnector3">
+              <a:avLst>
+                <a:gd name="adj1" fmla="val 50000"/>
+              </a:avLst>
+            </a:prstGeom>
+            <a:ln w="63500">
+              <a:solidFill>
+                <a:schemeClr val="tx1">
+                  <a:lumMod val="50000"/>
+                  <a:lumOff val="50000"/>
+                </a:schemeClr>
+              </a:solidFill>
+              <a:prstDash val="sysDot"/>
+            </a:ln>
+          </p:spPr>
+          <p:style>
+            <a:lnRef idx="2">
+              <a:schemeClr val="accent1"/>
+            </a:lnRef>
+            <a:fillRef idx="0">
+              <a:schemeClr val="accent1"/>
+            </a:fillRef>
+            <a:effectRef idx="1">
+              <a:schemeClr val="accent1"/>
+            </a:effectRef>
+            <a:fontRef idx="minor">
+              <a:schemeClr val="tx1"/>
+            </a:fontRef>
+          </p:style>
+        </p:cxnSp>
+        <p:sp>
+          <p:nvSpPr>
+            <p:cNvPr id="302" name="円/楕円 301">
+              <a:extLst>
+                <a:ext uri="{FF2B5EF4-FFF2-40B4-BE49-F238E27FC236}">
+                  <a16:creationId xmlns:a16="http://schemas.microsoft.com/office/drawing/2014/main" id="{112F4234-71D8-478E-E315-609033F0A880}"/>
+                </a:ext>
+              </a:extLst>
+            </p:cNvPr>
+            <p:cNvSpPr/>
+            <p:nvPr/>
+          </p:nvSpPr>
+          <p:spPr>
+            <a:xfrm rot="10800000">
+              <a:off x="6022484" y="3854831"/>
+              <a:ext cx="168339" cy="174795"/>
+            </a:xfrm>
+            <a:prstGeom prst="ellipse">
+              <a:avLst/>
+            </a:prstGeom>
+            <a:solidFill>
+              <a:schemeClr val="bg1"/>
+            </a:solidFill>
+            <a:ln>
+              <a:solidFill>
+                <a:schemeClr val="tx1"/>
+              </a:solidFill>
+            </a:ln>
+          </p:spPr>
+          <p:style>
+            <a:lnRef idx="2">
+              <a:schemeClr val="accent1">
+                <a:shade val="15000"/>
+              </a:schemeClr>
+            </a:lnRef>
+            <a:fillRef idx="1">
+              <a:schemeClr val="accent1"/>
+            </a:fillRef>
+            <a:effectRef idx="0">
+              <a:schemeClr val="accent1"/>
+            </a:effectRef>
+            <a:fontRef idx="minor">
+              <a:schemeClr val="lt1"/>
+            </a:fontRef>
+          </p:style>
+          <p:txBody>
+            <a:bodyPr rtlCol="0" anchor="ctr"/>
+            <a:lstStyle/>
+            <a:p>
+              <a:pPr algn="ctr"/>
+              <a:endParaRPr kumimoji="1" lang="ja-JP" altLang="en-US"/>
+            </a:p>
+          </p:txBody>
+        </p:sp>
+        <p:sp>
+          <p:nvSpPr>
+            <p:cNvPr id="13" name="円/楕円 12">
+              <a:extLst>
+                <a:ext uri="{FF2B5EF4-FFF2-40B4-BE49-F238E27FC236}">
+                  <a16:creationId xmlns:a16="http://schemas.microsoft.com/office/drawing/2014/main" id="{4C70BD3A-CA85-7EA8-543D-88C12DDD0143}"/>
+                </a:ext>
+              </a:extLst>
+            </p:cNvPr>
+            <p:cNvSpPr/>
+            <p:nvPr/>
+          </p:nvSpPr>
+          <p:spPr>
+            <a:xfrm rot="10800000">
+              <a:off x="5076640" y="3532941"/>
+              <a:ext cx="168339" cy="174795"/>
+            </a:xfrm>
+            <a:prstGeom prst="ellipse">
+              <a:avLst/>
+            </a:prstGeom>
+            <a:solidFill>
+              <a:schemeClr val="bg1"/>
+            </a:solidFill>
+            <a:ln>
+              <a:solidFill>
+                <a:schemeClr val="tx1"/>
+              </a:solidFill>
+            </a:ln>
+          </p:spPr>
+          <p:style>
+            <a:lnRef idx="2">
+              <a:schemeClr val="accent1">
+                <a:shade val="15000"/>
+              </a:schemeClr>
+            </a:lnRef>
+            <a:fillRef idx="1">
+              <a:schemeClr val="accent1"/>
+            </a:fillRef>
+            <a:effectRef idx="0">
+              <a:schemeClr val="accent1"/>
+            </a:effectRef>
+            <a:fontRef idx="minor">
+              <a:schemeClr val="lt1"/>
+            </a:fontRef>
+          </p:style>
+          <p:txBody>
+            <a:bodyPr rtlCol="0" anchor="ctr"/>
+            <a:lstStyle/>
+            <a:p>
+              <a:pPr algn="ctr"/>
+              <a:endParaRPr kumimoji="1" lang="ja-JP" altLang="en-US"/>
+            </a:p>
+          </p:txBody>
+        </p:sp>
+        <p:sp>
+          <p:nvSpPr>
+            <p:cNvPr id="20" name="円/楕円 19">
+              <a:extLst>
+                <a:ext uri="{FF2B5EF4-FFF2-40B4-BE49-F238E27FC236}">
+                  <a16:creationId xmlns:a16="http://schemas.microsoft.com/office/drawing/2014/main" id="{BAC35295-F138-CAE5-15E3-39AA1680C898}"/>
+                </a:ext>
+              </a:extLst>
+            </p:cNvPr>
+            <p:cNvSpPr/>
+            <p:nvPr/>
+          </p:nvSpPr>
+          <p:spPr>
+            <a:xfrm rot="10800000">
+              <a:off x="5086536" y="3214287"/>
+              <a:ext cx="168339" cy="174795"/>
+            </a:xfrm>
+            <a:prstGeom prst="ellipse">
+              <a:avLst/>
+            </a:prstGeom>
+            <a:solidFill>
+              <a:schemeClr val="bg1"/>
+            </a:solidFill>
+            <a:ln>
+              <a:solidFill>
+                <a:schemeClr val="tx1"/>
+              </a:solidFill>
+            </a:ln>
+          </p:spPr>
+          <p:style>
+            <a:lnRef idx="2">
+              <a:schemeClr val="accent1">
+                <a:shade val="15000"/>
+              </a:schemeClr>
+            </a:lnRef>
+            <a:fillRef idx="1">
+              <a:schemeClr val="accent1"/>
+            </a:fillRef>
+            <a:effectRef idx="0">
+              <a:schemeClr val="accent1"/>
+            </a:effectRef>
+            <a:fontRef idx="minor">
+              <a:schemeClr val="lt1"/>
+            </a:fontRef>
+          </p:style>
+          <p:txBody>
+            <a:bodyPr rtlCol="0" anchor="ctr"/>
+            <a:lstStyle/>
+            <a:p>
+              <a:pPr algn="ctr"/>
+              <a:endParaRPr kumimoji="1" lang="ja-JP" altLang="en-US"/>
+            </a:p>
+          </p:txBody>
+        </p:sp>
+        <p:sp>
+          <p:nvSpPr>
+            <p:cNvPr id="28" name="円/楕円 27">
+              <a:extLst>
+                <a:ext uri="{FF2B5EF4-FFF2-40B4-BE49-F238E27FC236}">
+                  <a16:creationId xmlns:a16="http://schemas.microsoft.com/office/drawing/2014/main" id="{B50DA537-EE25-FCA0-B8D9-7F4CEA143662}"/>
+                </a:ext>
+              </a:extLst>
+            </p:cNvPr>
+            <p:cNvSpPr/>
+            <p:nvPr/>
+          </p:nvSpPr>
+          <p:spPr>
+            <a:xfrm rot="10800000">
+              <a:off x="6022707" y="4154414"/>
+              <a:ext cx="168339" cy="174795"/>
+            </a:xfrm>
+            <a:prstGeom prst="ellipse">
+              <a:avLst/>
+            </a:prstGeom>
+            <a:solidFill>
+              <a:schemeClr val="bg1"/>
+            </a:solidFill>
+            <a:ln>
+              <a:solidFill>
+                <a:schemeClr val="tx1"/>
+              </a:solidFill>
+            </a:ln>
+          </p:spPr>
+          <p:style>
+            <a:lnRef idx="2">
+              <a:schemeClr val="accent1">
+                <a:shade val="15000"/>
+              </a:schemeClr>
+            </a:lnRef>
+            <a:fillRef idx="1">
+              <a:schemeClr val="accent1"/>
+            </a:fillRef>
+            <a:effectRef idx="0">
+              <a:schemeClr val="accent1"/>
+            </a:effectRef>
+            <a:fontRef idx="minor">
+              <a:schemeClr val="lt1"/>
+            </a:fontRef>
+          </p:style>
+          <p:txBody>
+            <a:bodyPr rtlCol="0" anchor="ctr"/>
+            <a:lstStyle/>
+            <a:p>
+              <a:pPr algn="ctr"/>
+              <a:endParaRPr kumimoji="1" lang="ja-JP" altLang="en-US"/>
+            </a:p>
+          </p:txBody>
+        </p:sp>
+        <p:sp>
+          <p:nvSpPr>
+            <p:cNvPr id="30" name="円/楕円 29">
+              <a:extLst>
+                <a:ext uri="{FF2B5EF4-FFF2-40B4-BE49-F238E27FC236}">
+                  <a16:creationId xmlns:a16="http://schemas.microsoft.com/office/drawing/2014/main" id="{11357DC4-D384-FE22-AF96-31559E62160F}"/>
+                </a:ext>
+              </a:extLst>
+            </p:cNvPr>
+            <p:cNvSpPr/>
+            <p:nvPr/>
+          </p:nvSpPr>
+          <p:spPr>
+            <a:xfrm rot="10800000">
+              <a:off x="6020729" y="3206368"/>
+              <a:ext cx="168339" cy="174795"/>
+            </a:xfrm>
+            <a:prstGeom prst="ellipse">
+              <a:avLst/>
+            </a:prstGeom>
+            <a:solidFill>
+              <a:schemeClr val="bg1"/>
+            </a:solidFill>
+            <a:ln>
+              <a:solidFill>
+                <a:schemeClr val="tx1"/>
+              </a:solidFill>
+            </a:ln>
+          </p:spPr>
+          <p:style>
+            <a:lnRef idx="2">
+              <a:schemeClr val="accent1">
+                <a:shade val="15000"/>
+              </a:schemeClr>
+            </a:lnRef>
+            <a:fillRef idx="1">
+              <a:schemeClr val="accent1"/>
+            </a:fillRef>
+            <a:effectRef idx="0">
+              <a:schemeClr val="accent1"/>
+            </a:effectRef>
+            <a:fontRef idx="minor">
+              <a:schemeClr val="lt1"/>
+            </a:fontRef>
+          </p:style>
+          <p:txBody>
+            <a:bodyPr rtlCol="0" anchor="ctr"/>
+            <a:lstStyle/>
+            <a:p>
+              <a:pPr algn="ctr"/>
+              <a:endParaRPr kumimoji="1" lang="ja-JP" altLang="en-US"/>
+            </a:p>
+          </p:txBody>
+        </p:sp>
+        <p:sp>
+          <p:nvSpPr>
+            <p:cNvPr id="36" name="円/楕円 35">
+              <a:extLst>
+                <a:ext uri="{FF2B5EF4-FFF2-40B4-BE49-F238E27FC236}">
+                  <a16:creationId xmlns:a16="http://schemas.microsoft.com/office/drawing/2014/main" id="{5E0E293C-115D-AC3D-841A-E7F517AE377F}"/>
+                </a:ext>
+              </a:extLst>
+            </p:cNvPr>
+            <p:cNvSpPr/>
+            <p:nvPr/>
+          </p:nvSpPr>
+          <p:spPr>
+            <a:xfrm rot="10800000">
+              <a:off x="5074662" y="4164313"/>
+              <a:ext cx="168339" cy="174795"/>
+            </a:xfrm>
+            <a:prstGeom prst="ellipse">
+              <a:avLst/>
+            </a:prstGeom>
+            <a:solidFill>
+              <a:schemeClr val="bg1"/>
+            </a:solidFill>
+            <a:ln>
+              <a:solidFill>
+                <a:schemeClr val="tx1"/>
+              </a:solidFill>
+            </a:ln>
+          </p:spPr>
+          <p:style>
+            <a:lnRef idx="2">
+              <a:schemeClr val="accent1">
+                <a:shade val="15000"/>
+              </a:schemeClr>
+            </a:lnRef>
+            <a:fillRef idx="1">
+              <a:schemeClr val="accent1"/>
+            </a:fillRef>
+            <a:effectRef idx="0">
+              <a:schemeClr val="accent1"/>
+            </a:effectRef>
+            <a:fontRef idx="minor">
+              <a:schemeClr val="lt1"/>
+            </a:fontRef>
+          </p:style>
+          <p:txBody>
+            <a:bodyPr rtlCol="0" anchor="ctr"/>
+            <a:lstStyle/>
+            <a:p>
+              <a:pPr algn="ctr"/>
+              <a:endParaRPr kumimoji="1" lang="ja-JP" altLang="en-US"/>
+            </a:p>
+          </p:txBody>
+        </p:sp>
+        <p:sp>
+          <p:nvSpPr>
+            <p:cNvPr id="37" name="円/楕円 36">
+              <a:extLst>
+                <a:ext uri="{FF2B5EF4-FFF2-40B4-BE49-F238E27FC236}">
+                  <a16:creationId xmlns:a16="http://schemas.microsoft.com/office/drawing/2014/main" id="{EE1D514D-E009-381E-D998-1F49FDA6DA25}"/>
+                </a:ext>
+              </a:extLst>
+            </p:cNvPr>
+            <p:cNvSpPr/>
+            <p:nvPr/>
+          </p:nvSpPr>
+          <p:spPr>
+            <a:xfrm rot="10800000">
+              <a:off x="6034583" y="3536900"/>
+              <a:ext cx="168339" cy="174795"/>
+            </a:xfrm>
+            <a:prstGeom prst="ellipse">
+              <a:avLst/>
+            </a:prstGeom>
+            <a:solidFill>
+              <a:schemeClr val="bg1"/>
+            </a:solidFill>
+            <a:ln>
+              <a:solidFill>
+                <a:schemeClr val="tx1"/>
+              </a:solidFill>
+            </a:ln>
+          </p:spPr>
+          <p:style>
+            <a:lnRef idx="2">
+              <a:schemeClr val="accent1">
+                <a:shade val="15000"/>
+              </a:schemeClr>
+            </a:lnRef>
+            <a:fillRef idx="1">
+              <a:schemeClr val="accent1"/>
+            </a:fillRef>
+            <a:effectRef idx="0">
+              <a:schemeClr val="accent1"/>
+            </a:effectRef>
+            <a:fontRef idx="minor">
+              <a:schemeClr val="lt1"/>
+            </a:fontRef>
+          </p:style>
+          <p:txBody>
+            <a:bodyPr rtlCol="0" anchor="ctr"/>
+            <a:lstStyle/>
+            <a:p>
+              <a:pPr algn="ctr"/>
+              <a:endParaRPr kumimoji="1" lang="ja-JP" altLang="en-US"/>
+            </a:p>
+          </p:txBody>
+        </p:sp>
+        <p:sp>
+          <p:nvSpPr>
+            <p:cNvPr id="71" name="円/楕円 70">
+              <a:extLst>
+                <a:ext uri="{FF2B5EF4-FFF2-40B4-BE49-F238E27FC236}">
+                  <a16:creationId xmlns:a16="http://schemas.microsoft.com/office/drawing/2014/main" id="{5F6FFBE0-78BA-9BDE-64BF-3881F8EBE76D}"/>
+                </a:ext>
+              </a:extLst>
+            </p:cNvPr>
+            <p:cNvSpPr/>
+            <p:nvPr/>
+          </p:nvSpPr>
+          <p:spPr>
+            <a:xfrm rot="10800000">
+              <a:off x="5611031" y="3532939"/>
+              <a:ext cx="168339" cy="174795"/>
+            </a:xfrm>
+            <a:prstGeom prst="ellipse">
+              <a:avLst/>
+            </a:prstGeom>
+            <a:solidFill>
+              <a:schemeClr val="bg1"/>
+            </a:solidFill>
+            <a:ln>
+              <a:solidFill>
+                <a:schemeClr val="tx1"/>
+              </a:solidFill>
+            </a:ln>
+          </p:spPr>
+          <p:style>
+            <a:lnRef idx="2">
+              <a:schemeClr val="accent1">
+                <a:shade val="15000"/>
+              </a:schemeClr>
+            </a:lnRef>
+            <a:fillRef idx="1">
+              <a:schemeClr val="accent1"/>
+            </a:fillRef>
+            <a:effectRef idx="0">
+              <a:schemeClr val="accent1"/>
+            </a:effectRef>
+            <a:fontRef idx="minor">
+              <a:schemeClr val="lt1"/>
+            </a:fontRef>
+          </p:style>
+          <p:txBody>
+            <a:bodyPr rtlCol="0" anchor="ctr"/>
+            <a:lstStyle/>
+            <a:p>
+              <a:pPr algn="ctr"/>
+              <a:endParaRPr kumimoji="1" lang="ja-JP" altLang="en-US"/>
+            </a:p>
+          </p:txBody>
+        </p:sp>
+        <p:sp>
+          <p:nvSpPr>
+            <p:cNvPr id="52" name="円/楕円 51">
+              <a:extLst>
+                <a:ext uri="{FF2B5EF4-FFF2-40B4-BE49-F238E27FC236}">
+                  <a16:creationId xmlns:a16="http://schemas.microsoft.com/office/drawing/2014/main" id="{D073A55C-E93E-34B8-BC1A-AEC153177911}"/>
+                </a:ext>
+              </a:extLst>
+            </p:cNvPr>
+            <p:cNvSpPr/>
+            <p:nvPr/>
+          </p:nvSpPr>
+          <p:spPr>
+            <a:xfrm rot="10800000">
+              <a:off x="5084559" y="3841701"/>
+              <a:ext cx="168339" cy="174795"/>
+            </a:xfrm>
+            <a:prstGeom prst="ellipse">
+              <a:avLst/>
+            </a:prstGeom>
+            <a:solidFill>
+              <a:schemeClr val="bg1"/>
+            </a:solidFill>
+            <a:ln>
+              <a:solidFill>
+                <a:schemeClr val="tx1"/>
+              </a:solidFill>
+            </a:ln>
+          </p:spPr>
+          <p:style>
+            <a:lnRef idx="2">
+              <a:schemeClr val="accent1">
+                <a:shade val="15000"/>
+              </a:schemeClr>
+            </a:lnRef>
+            <a:fillRef idx="1">
+              <a:schemeClr val="accent1"/>
+            </a:fillRef>
+            <a:effectRef idx="0">
+              <a:schemeClr val="accent1"/>
+            </a:effectRef>
+            <a:fontRef idx="minor">
+              <a:schemeClr val="lt1"/>
+            </a:fontRef>
+          </p:style>
+          <p:txBody>
+            <a:bodyPr rtlCol="0" anchor="ctr"/>
+            <a:lstStyle/>
+            <a:p>
+              <a:pPr algn="ctr"/>
+              <a:endParaRPr kumimoji="1" lang="ja-JP" altLang="en-US"/>
+            </a:p>
+          </p:txBody>
+        </p:sp>
+        <p:cxnSp>
+          <p:nvCxnSpPr>
+            <p:cNvPr id="65" name="カギ線コネクタ 64">
+              <a:extLst>
+                <a:ext uri="{FF2B5EF4-FFF2-40B4-BE49-F238E27FC236}">
+                  <a16:creationId xmlns:a16="http://schemas.microsoft.com/office/drawing/2014/main" id="{6F1D7049-6415-8EDA-76F7-26D6EEDF5279}"/>
+                </a:ext>
+              </a:extLst>
+            </p:cNvPr>
+            <p:cNvCxnSpPr>
+              <a:cxnSpLocks/>
+              <a:stCxn id="71" idx="6"/>
+              <a:endCxn id="52" idx="2"/>
+            </p:cNvCxnSpPr>
+            <p:nvPr/>
+          </p:nvCxnSpPr>
+          <p:spPr>
+            <a:xfrm rot="10800000" flipV="1">
+              <a:off x="5252898" y="3620336"/>
+              <a:ext cx="358133" cy="308762"/>
+            </a:xfrm>
+            <a:prstGeom prst="bentConnector3">
+              <a:avLst>
+                <a:gd name="adj1" fmla="val 50000"/>
+              </a:avLst>
+            </a:prstGeom>
+            <a:ln w="63500">
+              <a:solidFill>
+                <a:schemeClr val="tx1">
+                  <a:lumMod val="50000"/>
+                  <a:lumOff val="50000"/>
+                </a:schemeClr>
+              </a:solidFill>
+              <a:prstDash val="sysDot"/>
+            </a:ln>
+          </p:spPr>
+          <p:style>
+            <a:lnRef idx="2">
+              <a:schemeClr val="accent1"/>
+            </a:lnRef>
+            <a:fillRef idx="0">
+              <a:schemeClr val="accent1"/>
+            </a:fillRef>
+            <a:effectRef idx="1">
+              <a:schemeClr val="accent1"/>
+            </a:effectRef>
+            <a:fontRef idx="minor">
+              <a:schemeClr val="tx1"/>
+            </a:fontRef>
+          </p:style>
+        </p:cxnSp>
+      </p:grpSp>
+      <p:sp>
+        <p:nvSpPr>
+          <p:cNvPr id="55" name="正方形/長方形 54">
+            <a:extLst>
+              <a:ext uri="{FF2B5EF4-FFF2-40B4-BE49-F238E27FC236}">
+                <a16:creationId xmlns:a16="http://schemas.microsoft.com/office/drawing/2014/main" id="{3753A14B-242F-5788-63D4-AF9303585198}"/>
+              </a:ext>
+            </a:extLst>
+          </p:cNvPr>
+          <p:cNvSpPr/>
+          <p:nvPr/>
+        </p:nvSpPr>
+        <p:spPr>
+          <a:xfrm>
+            <a:off x="8319226" y="1582151"/>
+            <a:ext cx="304622" cy="2399924"/>
+          </a:xfrm>
+          <a:prstGeom prst="rect">
+            <a:avLst/>
+          </a:prstGeom>
+        </p:spPr>
+        <p:style>
+          <a:lnRef idx="2">
+            <a:schemeClr val="accent1">
+              <a:shade val="15000"/>
+            </a:schemeClr>
+          </a:lnRef>
+          <a:fillRef idx="1">
+            <a:schemeClr val="accent1"/>
+          </a:fillRef>
+          <a:effectRef idx="0">
+            <a:schemeClr val="accent1"/>
+          </a:effectRef>
+          <a:fontRef idx="minor">
+            <a:schemeClr val="lt1"/>
+          </a:fontRef>
+        </p:style>
+        <p:txBody>
+          <a:bodyPr rtlCol="0" anchor="ctr"/>
+          <a:lstStyle/>
+          <a:p>
+            <a:pPr algn="ctr"/>
+            <a:endParaRPr kumimoji="1" lang="ja-JP" altLang="en-US"/>
+          </a:p>
+        </p:txBody>
+      </p:sp>
+      <p:grpSp>
+        <p:nvGrpSpPr>
+          <p:cNvPr id="66" name="グループ化 65">
+            <a:extLst>
+              <a:ext uri="{FF2B5EF4-FFF2-40B4-BE49-F238E27FC236}">
+                <a16:creationId xmlns:a16="http://schemas.microsoft.com/office/drawing/2014/main" id="{CBC92C1A-861D-FDC8-DE2A-EFF82ADEB76F}"/>
+              </a:ext>
+            </a:extLst>
+          </p:cNvPr>
+          <p:cNvGrpSpPr/>
+          <p:nvPr/>
+        </p:nvGrpSpPr>
+        <p:grpSpPr>
+          <a:xfrm>
+            <a:off x="8367579" y="1605506"/>
+            <a:ext cx="195648" cy="2000390"/>
+            <a:chOff x="7331138" y="1309815"/>
+            <a:chExt cx="195648" cy="2000390"/>
+          </a:xfrm>
+        </p:grpSpPr>
+        <p:grpSp>
+          <p:nvGrpSpPr>
+            <p:cNvPr id="60" name="グループ化 59">
+              <a:extLst>
+                <a:ext uri="{FF2B5EF4-FFF2-40B4-BE49-F238E27FC236}">
+                  <a16:creationId xmlns:a16="http://schemas.microsoft.com/office/drawing/2014/main" id="{35E63B24-C2EA-D8A5-0F82-A60979F6C332}"/>
+                </a:ext>
+              </a:extLst>
+            </p:cNvPr>
+            <p:cNvGrpSpPr/>
+            <p:nvPr/>
+          </p:nvGrpSpPr>
+          <p:grpSpPr>
+            <a:xfrm>
+              <a:off x="7341967" y="1309815"/>
+              <a:ext cx="184819" cy="1097435"/>
+              <a:chOff x="7341967" y="1309815"/>
+              <a:chExt cx="184819" cy="1097435"/>
+            </a:xfrm>
+          </p:grpSpPr>
+          <p:sp>
+            <p:nvSpPr>
+              <p:cNvPr id="56" name="円/楕円 55">
+                <a:extLst>
+                  <a:ext uri="{FF2B5EF4-FFF2-40B4-BE49-F238E27FC236}">
+                    <a16:creationId xmlns:a16="http://schemas.microsoft.com/office/drawing/2014/main" id="{CC4AF59A-F126-6253-D6F8-95FF5025BC5A}"/>
+                  </a:ext>
+                </a:extLst>
+              </p:cNvPr>
+              <p:cNvSpPr/>
+              <p:nvPr/>
+            </p:nvSpPr>
+            <p:spPr>
+              <a:xfrm>
+                <a:off x="7358447" y="1309815"/>
+                <a:ext cx="168339" cy="174795"/>
+              </a:xfrm>
+              <a:prstGeom prst="ellipse">
+                <a:avLst/>
+              </a:prstGeom>
+              <a:solidFill>
+                <a:schemeClr val="bg1"/>
+              </a:solidFill>
+              <a:ln>
+                <a:solidFill>
+                  <a:schemeClr val="tx1"/>
+                </a:solidFill>
+              </a:ln>
+            </p:spPr>
+            <p:style>
+              <a:lnRef idx="2">
+                <a:schemeClr val="accent1">
+                  <a:shade val="15000"/>
+                </a:schemeClr>
+              </a:lnRef>
+              <a:fillRef idx="1">
+                <a:schemeClr val="accent1"/>
+              </a:fillRef>
+              <a:effectRef idx="0">
+                <a:schemeClr val="accent1"/>
+              </a:effectRef>
+              <a:fontRef idx="minor">
+                <a:schemeClr val="lt1"/>
+              </a:fontRef>
+            </p:style>
+            <p:txBody>
+              <a:bodyPr rtlCol="0" anchor="ctr"/>
+              <a:lstStyle/>
+              <a:p>
+                <a:pPr algn="ctr"/>
+                <a:endParaRPr kumimoji="1" lang="ja-JP" altLang="en-US"/>
+              </a:p>
+            </p:txBody>
+          </p:sp>
+          <p:sp>
+            <p:nvSpPr>
+              <p:cNvPr id="57" name="円/楕円 56">
+                <a:extLst>
+                  <a:ext uri="{FF2B5EF4-FFF2-40B4-BE49-F238E27FC236}">
+                    <a16:creationId xmlns:a16="http://schemas.microsoft.com/office/drawing/2014/main" id="{582FF93E-4B46-327A-B054-84F04E5A6874}"/>
+                  </a:ext>
+                </a:extLst>
+              </p:cNvPr>
+              <p:cNvSpPr/>
+              <p:nvPr/>
+            </p:nvSpPr>
+            <p:spPr>
+              <a:xfrm>
+                <a:off x="7350207" y="1622853"/>
+                <a:ext cx="168339" cy="174795"/>
+              </a:xfrm>
+              <a:prstGeom prst="ellipse">
+                <a:avLst/>
+              </a:prstGeom>
+              <a:solidFill>
+                <a:schemeClr val="bg1"/>
+              </a:solidFill>
+              <a:ln>
+                <a:solidFill>
+                  <a:schemeClr val="tx1"/>
+                </a:solidFill>
+              </a:ln>
+            </p:spPr>
+            <p:style>
+              <a:lnRef idx="2">
+                <a:schemeClr val="accent1">
+                  <a:shade val="15000"/>
+                </a:schemeClr>
+              </a:lnRef>
+              <a:fillRef idx="1">
+                <a:schemeClr val="accent1"/>
+              </a:fillRef>
+              <a:effectRef idx="0">
+                <a:schemeClr val="accent1"/>
+              </a:effectRef>
+              <a:fontRef idx="minor">
+                <a:schemeClr val="lt1"/>
+              </a:fontRef>
+            </p:style>
+            <p:txBody>
+              <a:bodyPr rtlCol="0" anchor="ctr"/>
+              <a:lstStyle/>
+              <a:p>
+                <a:pPr algn="ctr"/>
+                <a:endParaRPr kumimoji="1" lang="ja-JP" altLang="en-US"/>
+              </a:p>
+            </p:txBody>
+          </p:sp>
+          <p:sp>
+            <p:nvSpPr>
+              <p:cNvPr id="58" name="円/楕円 57">
+                <a:extLst>
+                  <a:ext uri="{FF2B5EF4-FFF2-40B4-BE49-F238E27FC236}">
+                    <a16:creationId xmlns:a16="http://schemas.microsoft.com/office/drawing/2014/main" id="{AD5E25D9-A6DE-C95F-FCE1-800E743DA1D5}"/>
+                  </a:ext>
+                </a:extLst>
+              </p:cNvPr>
+              <p:cNvSpPr/>
+              <p:nvPr/>
+            </p:nvSpPr>
+            <p:spPr>
+              <a:xfrm>
+                <a:off x="7350207" y="1919417"/>
+                <a:ext cx="168339" cy="174795"/>
+              </a:xfrm>
+              <a:prstGeom prst="ellipse">
+                <a:avLst/>
+              </a:prstGeom>
+              <a:solidFill>
+                <a:schemeClr val="bg1"/>
+              </a:solidFill>
+              <a:ln>
+                <a:solidFill>
+                  <a:schemeClr val="tx1"/>
+                </a:solidFill>
+              </a:ln>
+            </p:spPr>
+            <p:style>
+              <a:lnRef idx="2">
+                <a:schemeClr val="accent1">
+                  <a:shade val="15000"/>
+                </a:schemeClr>
+              </a:lnRef>
+              <a:fillRef idx="1">
+                <a:schemeClr val="accent1"/>
+              </a:fillRef>
+              <a:effectRef idx="0">
+                <a:schemeClr val="accent1"/>
+              </a:effectRef>
+              <a:fontRef idx="minor">
+                <a:schemeClr val="lt1"/>
+              </a:fontRef>
+            </p:style>
+            <p:txBody>
+              <a:bodyPr rtlCol="0" anchor="ctr"/>
+              <a:lstStyle/>
+              <a:p>
+                <a:pPr algn="ctr"/>
+                <a:endParaRPr kumimoji="1" lang="ja-JP" altLang="en-US"/>
+              </a:p>
+            </p:txBody>
+          </p:sp>
+          <p:sp>
+            <p:nvSpPr>
+              <p:cNvPr id="59" name="円/楕円 58">
+                <a:extLst>
+                  <a:ext uri="{FF2B5EF4-FFF2-40B4-BE49-F238E27FC236}">
+                    <a16:creationId xmlns:a16="http://schemas.microsoft.com/office/drawing/2014/main" id="{063B204A-3E57-5E97-960B-A82F62E7D812}"/>
+                  </a:ext>
+                </a:extLst>
+              </p:cNvPr>
+              <p:cNvSpPr/>
+              <p:nvPr/>
+            </p:nvSpPr>
+            <p:spPr>
+              <a:xfrm>
+                <a:off x="7341967" y="2232455"/>
+                <a:ext cx="168339" cy="174795"/>
+              </a:xfrm>
+              <a:prstGeom prst="ellipse">
+                <a:avLst/>
+              </a:prstGeom>
+              <a:solidFill>
+                <a:schemeClr val="bg1"/>
+              </a:solidFill>
+              <a:ln>
+                <a:solidFill>
+                  <a:schemeClr val="tx1"/>
+                </a:solidFill>
+              </a:ln>
+            </p:spPr>
+            <p:style>
+              <a:lnRef idx="2">
+                <a:schemeClr val="accent1">
+                  <a:shade val="15000"/>
+                </a:schemeClr>
+              </a:lnRef>
+              <a:fillRef idx="1">
+                <a:schemeClr val="accent1"/>
+              </a:fillRef>
+              <a:effectRef idx="0">
+                <a:schemeClr val="accent1"/>
+              </a:effectRef>
+              <a:fontRef idx="minor">
+                <a:schemeClr val="lt1"/>
+              </a:fontRef>
+            </p:style>
+            <p:txBody>
+              <a:bodyPr rtlCol="0" anchor="ctr"/>
+              <a:lstStyle/>
+              <a:p>
+                <a:pPr algn="ctr"/>
+                <a:endParaRPr kumimoji="1" lang="ja-JP" altLang="en-US"/>
+              </a:p>
+            </p:txBody>
+          </p:sp>
+        </p:grpSp>
+        <p:grpSp>
+          <p:nvGrpSpPr>
+            <p:cNvPr id="61" name="グループ化 60">
+              <a:extLst>
+                <a:ext uri="{FF2B5EF4-FFF2-40B4-BE49-F238E27FC236}">
+                  <a16:creationId xmlns:a16="http://schemas.microsoft.com/office/drawing/2014/main" id="{91A68626-8B00-AD1C-9EBA-63237E0418ED}"/>
+                </a:ext>
+              </a:extLst>
+            </p:cNvPr>
+            <p:cNvGrpSpPr/>
+            <p:nvPr/>
+          </p:nvGrpSpPr>
+          <p:grpSpPr>
+            <a:xfrm>
+              <a:off x="7331138" y="2525808"/>
+              <a:ext cx="176579" cy="784397"/>
+              <a:chOff x="7350207" y="1309815"/>
+              <a:chExt cx="176579" cy="784397"/>
+            </a:xfrm>
+          </p:grpSpPr>
+          <p:sp>
+            <p:nvSpPr>
+              <p:cNvPr id="62" name="円/楕円 61">
+                <a:extLst>
+                  <a:ext uri="{FF2B5EF4-FFF2-40B4-BE49-F238E27FC236}">
+                    <a16:creationId xmlns:a16="http://schemas.microsoft.com/office/drawing/2014/main" id="{C96C262A-953A-A7E2-E1A4-E153ED09FB93}"/>
+                  </a:ext>
+                </a:extLst>
+              </p:cNvPr>
+              <p:cNvSpPr/>
+              <p:nvPr/>
+            </p:nvSpPr>
+            <p:spPr>
+              <a:xfrm>
+                <a:off x="7358447" y="1309815"/>
+                <a:ext cx="168339" cy="174795"/>
+              </a:xfrm>
+              <a:prstGeom prst="ellipse">
+                <a:avLst/>
+              </a:prstGeom>
+              <a:solidFill>
+                <a:schemeClr val="bg1"/>
+              </a:solidFill>
+              <a:ln>
+                <a:solidFill>
+                  <a:schemeClr val="tx1"/>
+                </a:solidFill>
+              </a:ln>
+            </p:spPr>
+            <p:style>
+              <a:lnRef idx="2">
+                <a:schemeClr val="accent1">
+                  <a:shade val="15000"/>
+                </a:schemeClr>
+              </a:lnRef>
+              <a:fillRef idx="1">
+                <a:schemeClr val="accent1"/>
+              </a:fillRef>
+              <a:effectRef idx="0">
+                <a:schemeClr val="accent1"/>
+              </a:effectRef>
+              <a:fontRef idx="minor">
+                <a:schemeClr val="lt1"/>
+              </a:fontRef>
+            </p:style>
+            <p:txBody>
+              <a:bodyPr rtlCol="0" anchor="ctr"/>
+              <a:lstStyle/>
+              <a:p>
+                <a:pPr algn="ctr"/>
+                <a:endParaRPr kumimoji="1" lang="ja-JP" altLang="en-US"/>
+              </a:p>
+            </p:txBody>
+          </p:sp>
+          <p:sp>
+            <p:nvSpPr>
+              <p:cNvPr id="63" name="円/楕円 62">
+                <a:extLst>
+                  <a:ext uri="{FF2B5EF4-FFF2-40B4-BE49-F238E27FC236}">
+                    <a16:creationId xmlns:a16="http://schemas.microsoft.com/office/drawing/2014/main" id="{0605865D-A44A-2B30-BB9C-DEB813C5A3CF}"/>
+                  </a:ext>
+                </a:extLst>
+              </p:cNvPr>
+              <p:cNvSpPr/>
+              <p:nvPr/>
+            </p:nvSpPr>
+            <p:spPr>
+              <a:xfrm>
+                <a:off x="7350207" y="1622853"/>
+                <a:ext cx="168339" cy="174795"/>
+              </a:xfrm>
+              <a:prstGeom prst="ellipse">
+                <a:avLst/>
+              </a:prstGeom>
+              <a:solidFill>
+                <a:schemeClr val="bg1"/>
+              </a:solidFill>
+              <a:ln>
+                <a:solidFill>
+                  <a:schemeClr val="tx1"/>
+                </a:solidFill>
+              </a:ln>
+            </p:spPr>
+            <p:style>
+              <a:lnRef idx="2">
+                <a:schemeClr val="accent1">
+                  <a:shade val="15000"/>
+                </a:schemeClr>
+              </a:lnRef>
+              <a:fillRef idx="1">
+                <a:schemeClr val="accent1"/>
+              </a:fillRef>
+              <a:effectRef idx="0">
+                <a:schemeClr val="accent1"/>
+              </a:effectRef>
+              <a:fontRef idx="minor">
+                <a:schemeClr val="lt1"/>
+              </a:fontRef>
+            </p:style>
+            <p:txBody>
+              <a:bodyPr rtlCol="0" anchor="ctr"/>
+              <a:lstStyle/>
+              <a:p>
+                <a:pPr algn="ctr"/>
+                <a:endParaRPr kumimoji="1" lang="ja-JP" altLang="en-US"/>
+              </a:p>
+            </p:txBody>
+          </p:sp>
+          <p:sp>
+            <p:nvSpPr>
+              <p:cNvPr id="64" name="円/楕円 63">
+                <a:extLst>
+                  <a:ext uri="{FF2B5EF4-FFF2-40B4-BE49-F238E27FC236}">
+                    <a16:creationId xmlns:a16="http://schemas.microsoft.com/office/drawing/2014/main" id="{FFFC84E9-8423-2C6D-EE8C-07500CA0B942}"/>
+                  </a:ext>
+                </a:extLst>
+              </p:cNvPr>
+              <p:cNvSpPr/>
+              <p:nvPr/>
+            </p:nvSpPr>
+            <p:spPr>
+              <a:xfrm>
+                <a:off x="7350207" y="1919417"/>
+                <a:ext cx="168339" cy="174795"/>
+              </a:xfrm>
+              <a:prstGeom prst="ellipse">
+                <a:avLst/>
+              </a:prstGeom>
+              <a:solidFill>
+                <a:schemeClr val="bg1"/>
+              </a:solidFill>
+              <a:ln>
+                <a:solidFill>
+                  <a:schemeClr val="tx1"/>
+                </a:solidFill>
+              </a:ln>
+            </p:spPr>
+            <p:style>
+              <a:lnRef idx="2">
+                <a:schemeClr val="accent1">
+                  <a:shade val="15000"/>
+                </a:schemeClr>
+              </a:lnRef>
+              <a:fillRef idx="1">
+                <a:schemeClr val="accent1"/>
+              </a:fillRef>
+              <a:effectRef idx="0">
+                <a:schemeClr val="accent1"/>
+              </a:effectRef>
+              <a:fontRef idx="minor">
+                <a:schemeClr val="lt1"/>
+              </a:fontRef>
+            </p:style>
+            <p:txBody>
+              <a:bodyPr rtlCol="0" anchor="ctr"/>
+              <a:lstStyle/>
+              <a:p>
+                <a:pPr algn="ctr"/>
+                <a:endParaRPr kumimoji="1" lang="ja-JP" altLang="en-US"/>
+              </a:p>
+            </p:txBody>
+          </p:sp>
+        </p:grpSp>
+      </p:grpSp>
+      <p:sp>
+        <p:nvSpPr>
+          <p:cNvPr id="67" name="テキスト ボックス 66">
+            <a:extLst>
+              <a:ext uri="{FF2B5EF4-FFF2-40B4-BE49-F238E27FC236}">
+                <a16:creationId xmlns:a16="http://schemas.microsoft.com/office/drawing/2014/main" id="{F5E32B19-C5AC-9355-A655-5E2894E11F2B}"/>
+              </a:ext>
+            </a:extLst>
+          </p:cNvPr>
+          <p:cNvSpPr txBox="1"/>
+          <p:nvPr/>
+        </p:nvSpPr>
+        <p:spPr>
+          <a:xfrm>
+            <a:off x="8680441" y="1627951"/>
+            <a:ext cx="697627" cy="2031325"/>
+          </a:xfrm>
+          <a:prstGeom prst="rect">
+            <a:avLst/>
+          </a:prstGeom>
+          <a:noFill/>
+        </p:spPr>
+        <p:txBody>
+          <a:bodyPr wrap="none" rtlCol="0">
+            <a:spAutoFit/>
+          </a:bodyPr>
+          <a:lstStyle/>
+          <a:p>
+            <a:r>
+              <a:rPr kumimoji="1" lang="en-US" altLang="ja-JP" dirty="0"/>
+              <a:t>GND</a:t>
+            </a:r>
+          </a:p>
+          <a:p>
+            <a:r>
+              <a:rPr lang="en-US" altLang="ja-JP" dirty="0"/>
+              <a:t>VCC</a:t>
+            </a:r>
+          </a:p>
+          <a:p>
+            <a:r>
+              <a:rPr kumimoji="1" lang="en-US" altLang="ja-JP" dirty="0"/>
+              <a:t>SCL</a:t>
+            </a:r>
+          </a:p>
+          <a:p>
+            <a:r>
+              <a:rPr lang="en-US" altLang="ja-JP" dirty="0"/>
+              <a:t>SDA</a:t>
+            </a:r>
+          </a:p>
+          <a:p>
+            <a:r>
+              <a:rPr kumimoji="1" lang="en-US" altLang="ja-JP" dirty="0"/>
+              <a:t>RES</a:t>
+            </a:r>
+          </a:p>
+          <a:p>
+            <a:r>
+              <a:rPr kumimoji="1" lang="en-US" altLang="ja-JP" dirty="0"/>
+              <a:t>DC</a:t>
+            </a:r>
+          </a:p>
+          <a:p>
+            <a:r>
+              <a:rPr lang="en-US" altLang="ja-JP" dirty="0"/>
+              <a:t>CS</a:t>
+            </a:r>
+          </a:p>
+        </p:txBody>
+      </p:sp>
+      <p:cxnSp>
+        <p:nvCxnSpPr>
+          <p:cNvPr id="90" name="カギ線コネクタ 89">
+            <a:extLst>
+              <a:ext uri="{FF2B5EF4-FFF2-40B4-BE49-F238E27FC236}">
+                <a16:creationId xmlns:a16="http://schemas.microsoft.com/office/drawing/2014/main" id="{E0A4C6FC-77A8-FC15-E0D2-08AAE7430313}"/>
+              </a:ext>
+            </a:extLst>
+          </p:cNvPr>
+          <p:cNvCxnSpPr>
+            <a:cxnSpLocks/>
+            <a:stCxn id="80" idx="0"/>
+            <a:endCxn id="64" idx="2"/>
+          </p:cNvCxnSpPr>
+          <p:nvPr/>
+        </p:nvCxnSpPr>
+        <p:spPr>
+          <a:xfrm>
+            <a:off x="7594580" y="1592768"/>
+            <a:ext cx="772999" cy="1925731"/>
+          </a:xfrm>
+          <a:prstGeom prst="straightConnector1">
+            <a:avLst/>
+          </a:prstGeom>
+          <a:ln w="63500">
+            <a:solidFill>
+              <a:schemeClr val="accent2"/>
+            </a:solidFill>
+            <a:prstDash val="sysDot"/>
+          </a:ln>
+        </p:spPr>
+        <p:style>
+          <a:lnRef idx="2">
+            <a:schemeClr val="accent1"/>
+          </a:lnRef>
+          <a:fillRef idx="0">
+            <a:schemeClr val="accent1"/>
+          </a:fillRef>
+          <a:effectRef idx="1">
+            <a:schemeClr val="accent1"/>
+          </a:effectRef>
+          <a:fontRef idx="minor">
+            <a:schemeClr val="tx1"/>
+          </a:fontRef>
+        </p:style>
+      </p:cxnSp>
+      <p:cxnSp>
+        <p:nvCxnSpPr>
+          <p:cNvPr id="18" name="カギ線コネクタ 17">
+            <a:extLst>
+              <a:ext uri="{FF2B5EF4-FFF2-40B4-BE49-F238E27FC236}">
+                <a16:creationId xmlns:a16="http://schemas.microsoft.com/office/drawing/2014/main" id="{08F0763C-91C7-8CE8-C178-22E20AAAC456}"/>
+              </a:ext>
+            </a:extLst>
+          </p:cNvPr>
+          <p:cNvCxnSpPr>
+            <a:cxnSpLocks/>
+            <a:stCxn id="28" idx="6"/>
+            <a:endCxn id="30" idx="6"/>
+          </p:cNvCxnSpPr>
+          <p:nvPr/>
+        </p:nvCxnSpPr>
+        <p:spPr>
+          <a:xfrm>
+            <a:off x="4157276" y="2788481"/>
+            <a:ext cx="1978" cy="948046"/>
+          </a:xfrm>
+          <a:prstGeom prst="bentConnector3">
+            <a:avLst>
+              <a:gd name="adj1" fmla="val 11657128"/>
+            </a:avLst>
+          </a:prstGeom>
+          <a:ln w="63500">
+            <a:solidFill>
+              <a:srgbClr val="FF0000"/>
+            </a:solidFill>
+            <a:prstDash val="solid"/>
+          </a:ln>
+        </p:spPr>
+        <p:style>
+          <a:lnRef idx="2">
+            <a:schemeClr val="accent1"/>
+          </a:lnRef>
+          <a:fillRef idx="0">
+            <a:schemeClr val="accent1"/>
+          </a:fillRef>
+          <a:effectRef idx="1">
+            <a:schemeClr val="accent1"/>
+          </a:effectRef>
+          <a:fontRef idx="minor">
+            <a:schemeClr val="tx1"/>
+          </a:fontRef>
+        </p:style>
+      </p:cxnSp>
+      <p:cxnSp>
+        <p:nvCxnSpPr>
+          <p:cNvPr id="33" name="カギ線コネクタ 32">
+            <a:extLst>
+              <a:ext uri="{FF2B5EF4-FFF2-40B4-BE49-F238E27FC236}">
+                <a16:creationId xmlns:a16="http://schemas.microsoft.com/office/drawing/2014/main" id="{A1CBD64D-4545-840A-3463-EE4504C653BF}"/>
+              </a:ext>
+            </a:extLst>
+          </p:cNvPr>
+          <p:cNvCxnSpPr>
+            <a:cxnSpLocks/>
+            <a:stCxn id="20" idx="6"/>
+            <a:endCxn id="21" idx="6"/>
+          </p:cNvCxnSpPr>
+          <p:nvPr/>
+        </p:nvCxnSpPr>
+        <p:spPr>
+          <a:xfrm flipV="1">
+            <a:off x="5093447" y="3497820"/>
+            <a:ext cx="2417698" cy="230788"/>
+          </a:xfrm>
+          <a:prstGeom prst="bentConnector2">
+            <a:avLst/>
+          </a:prstGeom>
+          <a:ln w="63500">
+            <a:solidFill>
+              <a:srgbClr val="00B0F0"/>
+            </a:solidFill>
+            <a:prstDash val="sysDot"/>
+          </a:ln>
+        </p:spPr>
+        <p:style>
+          <a:lnRef idx="2">
+            <a:schemeClr val="accent1"/>
+          </a:lnRef>
+          <a:fillRef idx="0">
+            <a:schemeClr val="accent1"/>
+          </a:fillRef>
+          <a:effectRef idx="1">
+            <a:schemeClr val="accent1"/>
+          </a:effectRef>
+          <a:fontRef idx="minor">
+            <a:schemeClr val="tx1"/>
+          </a:fontRef>
+        </p:style>
+      </p:cxnSp>
+      <p:cxnSp>
+        <p:nvCxnSpPr>
+          <p:cNvPr id="50" name="カギ線コネクタ 49">
+            <a:extLst>
+              <a:ext uri="{FF2B5EF4-FFF2-40B4-BE49-F238E27FC236}">
+                <a16:creationId xmlns:a16="http://schemas.microsoft.com/office/drawing/2014/main" id="{EC932B0F-169A-CA8B-669F-65EDA45FDAB0}"/>
+              </a:ext>
+            </a:extLst>
+          </p:cNvPr>
+          <p:cNvCxnSpPr>
+            <a:cxnSpLocks/>
+            <a:stCxn id="13" idx="6"/>
+            <a:endCxn id="17" idx="4"/>
+          </p:cNvCxnSpPr>
+          <p:nvPr/>
+        </p:nvCxnSpPr>
+        <p:spPr>
+          <a:xfrm flipV="1">
+            <a:off x="5103343" y="3399794"/>
+            <a:ext cx="810259" cy="10160"/>
+          </a:xfrm>
+          <a:prstGeom prst="bentConnector3">
+            <a:avLst>
+              <a:gd name="adj1" fmla="val 50000"/>
+            </a:avLst>
+          </a:prstGeom>
+          <a:ln w="63500">
+            <a:solidFill>
+              <a:srgbClr val="00B050"/>
+            </a:solidFill>
+            <a:prstDash val="sysDot"/>
+          </a:ln>
+        </p:spPr>
+        <p:style>
+          <a:lnRef idx="2">
+            <a:schemeClr val="accent1"/>
+          </a:lnRef>
+          <a:fillRef idx="0">
+            <a:schemeClr val="accent1"/>
+          </a:fillRef>
+          <a:effectRef idx="1">
+            <a:schemeClr val="accent1"/>
+          </a:effectRef>
+          <a:fontRef idx="minor">
+            <a:schemeClr val="tx1"/>
+          </a:fontRef>
+        </p:style>
+      </p:cxnSp>
+      <p:cxnSp>
+        <p:nvCxnSpPr>
+          <p:cNvPr id="93" name="カギ線コネクタ 92">
+            <a:extLst>
+              <a:ext uri="{FF2B5EF4-FFF2-40B4-BE49-F238E27FC236}">
+                <a16:creationId xmlns:a16="http://schemas.microsoft.com/office/drawing/2014/main" id="{1422AF6A-32BA-8A07-A46D-EFEBE247BD1F}"/>
+              </a:ext>
+            </a:extLst>
+          </p:cNvPr>
+          <p:cNvCxnSpPr>
+            <a:cxnSpLocks/>
+            <a:stCxn id="301" idx="4"/>
+            <a:endCxn id="302" idx="6"/>
+          </p:cNvCxnSpPr>
+          <p:nvPr/>
+        </p:nvCxnSpPr>
+        <p:spPr>
+          <a:xfrm rot="10800000" flipV="1">
+            <a:off x="4157500" y="688262"/>
+            <a:ext cx="1764019" cy="2399801"/>
+          </a:xfrm>
+          <a:prstGeom prst="bentConnector3">
+            <a:avLst>
+              <a:gd name="adj1" fmla="val 90392"/>
+            </a:avLst>
+          </a:prstGeom>
+          <a:ln w="63500">
+            <a:solidFill>
+              <a:schemeClr val="accent5"/>
+            </a:solidFill>
+            <a:prstDash val="sysDot"/>
+          </a:ln>
+        </p:spPr>
+        <p:style>
+          <a:lnRef idx="2">
+            <a:schemeClr val="accent1"/>
+          </a:lnRef>
+          <a:fillRef idx="0">
+            <a:schemeClr val="accent1"/>
+          </a:fillRef>
+          <a:effectRef idx="1">
+            <a:schemeClr val="accent1"/>
+          </a:effectRef>
+          <a:fontRef idx="minor">
+            <a:schemeClr val="tx1"/>
+          </a:fontRef>
+        </p:style>
+      </p:cxnSp>
+      <p:cxnSp>
+        <p:nvCxnSpPr>
+          <p:cNvPr id="171" name="カギ線コネクタ 170">
+            <a:extLst>
+              <a:ext uri="{FF2B5EF4-FFF2-40B4-BE49-F238E27FC236}">
+                <a16:creationId xmlns:a16="http://schemas.microsoft.com/office/drawing/2014/main" id="{1AB5F148-AEAB-AD0C-128D-2F24898C269A}"/>
+              </a:ext>
+            </a:extLst>
+          </p:cNvPr>
+          <p:cNvCxnSpPr>
+            <a:cxnSpLocks/>
+            <a:stCxn id="95" idx="0"/>
+            <a:endCxn id="63" idx="2"/>
+          </p:cNvCxnSpPr>
+          <p:nvPr/>
+        </p:nvCxnSpPr>
+        <p:spPr>
+          <a:xfrm>
+            <a:off x="7596559" y="1297865"/>
+            <a:ext cx="771020" cy="1924070"/>
+          </a:xfrm>
+          <a:prstGeom prst="straightConnector1">
+            <a:avLst/>
+          </a:prstGeom>
+          <a:ln w="63500">
+            <a:solidFill>
+              <a:srgbClr val="00B0F0"/>
+            </a:solidFill>
+            <a:prstDash val="sysDot"/>
+          </a:ln>
+        </p:spPr>
+        <p:style>
+          <a:lnRef idx="2">
+            <a:schemeClr val="accent1"/>
+          </a:lnRef>
+          <a:fillRef idx="0">
+            <a:schemeClr val="accent1"/>
+          </a:fillRef>
+          <a:effectRef idx="1">
+            <a:schemeClr val="accent1"/>
+          </a:effectRef>
+          <a:fontRef idx="minor">
+            <a:schemeClr val="tx1"/>
+          </a:fontRef>
+        </p:style>
+      </p:cxnSp>
+      <p:cxnSp>
+        <p:nvCxnSpPr>
+          <p:cNvPr id="217" name="カギ線コネクタ 216">
+            <a:extLst>
+              <a:ext uri="{FF2B5EF4-FFF2-40B4-BE49-F238E27FC236}">
+                <a16:creationId xmlns:a16="http://schemas.microsoft.com/office/drawing/2014/main" id="{9013995A-D51C-BC43-67EB-B1A5158A5F4B}"/>
+              </a:ext>
+            </a:extLst>
+          </p:cNvPr>
+          <p:cNvCxnSpPr>
+            <a:cxnSpLocks/>
+            <a:stCxn id="56" idx="2"/>
+            <a:endCxn id="70" idx="0"/>
+          </p:cNvCxnSpPr>
+          <p:nvPr/>
+        </p:nvCxnSpPr>
+        <p:spPr>
+          <a:xfrm flipH="1">
+            <a:off x="7592602" y="1692904"/>
+            <a:ext cx="802286" cy="503523"/>
+          </a:xfrm>
+          <a:prstGeom prst="straightConnector1">
+            <a:avLst/>
+          </a:prstGeom>
+          <a:ln w="63500">
+            <a:solidFill>
+              <a:schemeClr val="tx1">
+                <a:lumMod val="50000"/>
+                <a:lumOff val="50000"/>
+              </a:schemeClr>
+            </a:solidFill>
+            <a:prstDash val="solid"/>
+          </a:ln>
+        </p:spPr>
+        <p:style>
+          <a:lnRef idx="2">
+            <a:schemeClr val="accent1"/>
+          </a:lnRef>
+          <a:fillRef idx="0">
+            <a:schemeClr val="accent1"/>
+          </a:fillRef>
+          <a:effectRef idx="1">
+            <a:schemeClr val="accent1"/>
+          </a:effectRef>
+          <a:fontRef idx="minor">
+            <a:schemeClr val="tx1"/>
+          </a:fontRef>
+        </p:style>
+      </p:cxnSp>
+      <p:cxnSp>
+        <p:nvCxnSpPr>
+          <p:cNvPr id="47" name="カギ線コネクタ 46">
+            <a:extLst>
+              <a:ext uri="{FF2B5EF4-FFF2-40B4-BE49-F238E27FC236}">
+                <a16:creationId xmlns:a16="http://schemas.microsoft.com/office/drawing/2014/main" id="{0B1F6B28-E487-7650-479F-E39B68201F1C}"/>
+              </a:ext>
+            </a:extLst>
+          </p:cNvPr>
+          <p:cNvCxnSpPr>
+            <a:cxnSpLocks/>
+            <a:stCxn id="53" idx="0"/>
+            <a:endCxn id="30" idx="4"/>
+          </p:cNvCxnSpPr>
+          <p:nvPr/>
+        </p:nvCxnSpPr>
+        <p:spPr>
+          <a:xfrm flipH="1">
+            <a:off x="4075085" y="2513106"/>
+            <a:ext cx="3525437" cy="1310818"/>
+          </a:xfrm>
+          <a:prstGeom prst="bentConnector4">
+            <a:avLst>
+              <a:gd name="adj1" fmla="val -6393"/>
+              <a:gd name="adj2" fmla="val 117439"/>
+            </a:avLst>
+          </a:prstGeom>
+          <a:ln w="63500">
+            <a:solidFill>
+              <a:srgbClr val="FF0000"/>
+            </a:solidFill>
+            <a:prstDash val="sysDot"/>
+          </a:ln>
+        </p:spPr>
+        <p:style>
+          <a:lnRef idx="2">
+            <a:schemeClr val="accent1"/>
+          </a:lnRef>
+          <a:fillRef idx="0">
+            <a:schemeClr val="accent1"/>
+          </a:fillRef>
+          <a:effectRef idx="1">
+            <a:schemeClr val="accent1"/>
+          </a:effectRef>
+          <a:fontRef idx="minor">
+            <a:schemeClr val="tx1"/>
+          </a:fontRef>
+        </p:style>
+      </p:cxnSp>
+      <p:cxnSp>
+        <p:nvCxnSpPr>
+          <p:cNvPr id="102" name="カギ線コネクタ 101">
+            <a:extLst>
+              <a:ext uri="{FF2B5EF4-FFF2-40B4-BE49-F238E27FC236}">
+                <a16:creationId xmlns:a16="http://schemas.microsoft.com/office/drawing/2014/main" id="{DF13A28E-B43F-95A1-0CCB-A8FE6F35D6C9}"/>
+              </a:ext>
+            </a:extLst>
+          </p:cNvPr>
+          <p:cNvCxnSpPr>
+            <a:cxnSpLocks/>
+            <a:stCxn id="101" idx="0"/>
+            <a:endCxn id="19" idx="4"/>
+          </p:cNvCxnSpPr>
+          <p:nvPr/>
+        </p:nvCxnSpPr>
+        <p:spPr>
+          <a:xfrm flipV="1">
+            <a:off x="6083900" y="377038"/>
+            <a:ext cx="386247" cy="618116"/>
+          </a:xfrm>
+          <a:prstGeom prst="bentConnector2">
+            <a:avLst/>
+          </a:prstGeom>
+          <a:ln w="63500">
+            <a:solidFill>
+              <a:srgbClr val="FFC000"/>
+            </a:solidFill>
+            <a:prstDash val="sysDot"/>
+          </a:ln>
+        </p:spPr>
+        <p:style>
+          <a:lnRef idx="2">
+            <a:schemeClr val="accent1"/>
+          </a:lnRef>
+          <a:fillRef idx="0">
+            <a:schemeClr val="accent1"/>
+          </a:fillRef>
+          <a:effectRef idx="1">
+            <a:schemeClr val="accent1"/>
+          </a:effectRef>
+          <a:fontRef idx="minor">
+            <a:schemeClr val="tx1"/>
+          </a:fontRef>
+        </p:style>
+      </p:cxnSp>
+      <p:cxnSp>
+        <p:nvCxnSpPr>
+          <p:cNvPr id="84" name="カギ線コネクタ 83">
+            <a:extLst>
+              <a:ext uri="{FF2B5EF4-FFF2-40B4-BE49-F238E27FC236}">
+                <a16:creationId xmlns:a16="http://schemas.microsoft.com/office/drawing/2014/main" id="{A3947912-1BCC-6E49-A9A2-F8BBA3A31DAF}"/>
+              </a:ext>
+            </a:extLst>
+          </p:cNvPr>
+          <p:cNvCxnSpPr>
+            <a:cxnSpLocks/>
+            <a:stCxn id="70" idx="4"/>
+            <a:endCxn id="36" idx="0"/>
+          </p:cNvCxnSpPr>
+          <p:nvPr/>
+        </p:nvCxnSpPr>
+        <p:spPr>
+          <a:xfrm rot="10800000" flipV="1">
+            <a:off x="5021153" y="2196426"/>
+            <a:ext cx="2396655" cy="494757"/>
+          </a:xfrm>
+          <a:prstGeom prst="bentConnector2">
+            <a:avLst/>
+          </a:prstGeom>
+          <a:ln w="63500">
+            <a:solidFill>
+              <a:schemeClr val="tx1">
+                <a:lumMod val="50000"/>
+                <a:lumOff val="50000"/>
+              </a:schemeClr>
+            </a:solidFill>
+            <a:prstDash val="solid"/>
+          </a:ln>
+        </p:spPr>
+        <p:style>
+          <a:lnRef idx="2">
+            <a:schemeClr val="accent1"/>
+          </a:lnRef>
+          <a:fillRef idx="0">
+            <a:schemeClr val="accent1"/>
+          </a:fillRef>
+          <a:effectRef idx="1">
+            <a:schemeClr val="accent1"/>
+          </a:effectRef>
+          <a:fontRef idx="minor">
+            <a:schemeClr val="tx1"/>
+          </a:fontRef>
+        </p:style>
+      </p:cxnSp>
+      <p:cxnSp>
+        <p:nvCxnSpPr>
+          <p:cNvPr id="78" name="カギ線コネクタ 77">
+            <a:extLst>
+              <a:ext uri="{FF2B5EF4-FFF2-40B4-BE49-F238E27FC236}">
+                <a16:creationId xmlns:a16="http://schemas.microsoft.com/office/drawing/2014/main" id="{0A4241DB-9B79-A192-C6EA-780E9468FE78}"/>
+              </a:ext>
+            </a:extLst>
+          </p:cNvPr>
+          <p:cNvCxnSpPr>
+            <a:cxnSpLocks/>
+            <a:stCxn id="74" idx="0"/>
+            <a:endCxn id="62" idx="2"/>
+          </p:cNvCxnSpPr>
+          <p:nvPr/>
+        </p:nvCxnSpPr>
+        <p:spPr>
+          <a:xfrm>
+            <a:off x="7570829" y="1002962"/>
+            <a:ext cx="804990" cy="1905935"/>
+          </a:xfrm>
+          <a:prstGeom prst="straightConnector1">
+            <a:avLst/>
+          </a:prstGeom>
+          <a:ln w="63500">
+            <a:solidFill>
+              <a:schemeClr val="accent6"/>
+            </a:solidFill>
+            <a:prstDash val="sysDot"/>
+          </a:ln>
+        </p:spPr>
+        <p:style>
+          <a:lnRef idx="2">
+            <a:schemeClr val="accent1"/>
+          </a:lnRef>
+          <a:fillRef idx="0">
+            <a:schemeClr val="accent1"/>
+          </a:fillRef>
+          <a:effectRef idx="1">
+            <a:schemeClr val="accent1"/>
+          </a:effectRef>
+          <a:fontRef idx="minor">
+            <a:schemeClr val="tx1"/>
+          </a:fontRef>
+        </p:style>
+      </p:cxnSp>
+      <p:cxnSp>
+        <p:nvCxnSpPr>
+          <p:cNvPr id="11" name="カギ線コネクタ 10">
+            <a:extLst>
+              <a:ext uri="{FF2B5EF4-FFF2-40B4-BE49-F238E27FC236}">
+                <a16:creationId xmlns:a16="http://schemas.microsoft.com/office/drawing/2014/main" id="{20561645-1787-CCAF-A1C6-D0390010BEF2}"/>
+              </a:ext>
+            </a:extLst>
+          </p:cNvPr>
+          <p:cNvCxnSpPr>
+            <a:cxnSpLocks/>
+            <a:stCxn id="57" idx="2"/>
+            <a:endCxn id="53" idx="0"/>
+          </p:cNvCxnSpPr>
+          <p:nvPr/>
+        </p:nvCxnSpPr>
+        <p:spPr>
+          <a:xfrm flipH="1">
+            <a:off x="7600522" y="2005942"/>
+            <a:ext cx="786126" cy="507164"/>
+          </a:xfrm>
+          <a:prstGeom prst="straightConnector1">
+            <a:avLst/>
+          </a:prstGeom>
+          <a:ln w="63500">
+            <a:solidFill>
+              <a:srgbClr val="FF0000"/>
+            </a:solidFill>
+          </a:ln>
+        </p:spPr>
+        <p:style>
+          <a:lnRef idx="2">
+            <a:schemeClr val="accent1"/>
+          </a:lnRef>
+          <a:fillRef idx="0">
+            <a:schemeClr val="accent1"/>
+          </a:fillRef>
+          <a:effectRef idx="1">
+            <a:schemeClr val="accent1"/>
+          </a:effectRef>
+          <a:fontRef idx="minor">
+            <a:schemeClr val="tx1"/>
+          </a:fontRef>
+        </p:style>
+      </p:cxnSp>
+      <p:sp>
+        <p:nvSpPr>
+          <p:cNvPr id="19" name="円/楕円 18">
+            <a:extLst>
+              <a:ext uri="{FF2B5EF4-FFF2-40B4-BE49-F238E27FC236}">
+                <a16:creationId xmlns:a16="http://schemas.microsoft.com/office/drawing/2014/main" id="{03BDAA98-2E9F-C8D3-202F-1869A9542B4A}"/>
+              </a:ext>
+            </a:extLst>
+          </p:cNvPr>
+          <p:cNvSpPr/>
+          <p:nvPr/>
+        </p:nvSpPr>
+        <p:spPr>
+          <a:xfrm>
+            <a:off x="6385977" y="202243"/>
+            <a:ext cx="168339" cy="174795"/>
+          </a:xfrm>
+          <a:prstGeom prst="ellipse">
+            <a:avLst/>
+          </a:prstGeom>
+          <a:solidFill>
+            <a:schemeClr val="bg1"/>
+          </a:solidFill>
+          <a:ln>
+            <a:solidFill>
+              <a:schemeClr val="tx1"/>
+            </a:solidFill>
+          </a:ln>
+        </p:spPr>
+        <p:style>
+          <a:lnRef idx="2">
+            <a:schemeClr val="accent1">
+              <a:shade val="15000"/>
+            </a:schemeClr>
+          </a:lnRef>
+          <a:fillRef idx="1">
+            <a:schemeClr val="accent1"/>
+          </a:fillRef>
+          <a:effectRef idx="0">
+            <a:schemeClr val="accent1"/>
+          </a:effectRef>
+          <a:fontRef idx="minor">
+            <a:schemeClr val="lt1"/>
+          </a:fontRef>
+        </p:style>
+        <p:txBody>
+          <a:bodyPr rtlCol="0" anchor="ctr"/>
+          <a:lstStyle/>
+          <a:p>
+            <a:pPr algn="ctr"/>
+            <a:endParaRPr kumimoji="1" lang="ja-JP" altLang="en-US"/>
+          </a:p>
+        </p:txBody>
+      </p:sp>
+      <p:sp>
+        <p:nvSpPr>
+          <p:cNvPr id="22" name="円/楕円 21">
+            <a:extLst>
+              <a:ext uri="{FF2B5EF4-FFF2-40B4-BE49-F238E27FC236}">
+                <a16:creationId xmlns:a16="http://schemas.microsoft.com/office/drawing/2014/main" id="{B3C69EAD-569C-1357-DC62-3930FF566E73}"/>
+              </a:ext>
+            </a:extLst>
+          </p:cNvPr>
+          <p:cNvSpPr/>
+          <p:nvPr/>
+        </p:nvSpPr>
+        <p:spPr>
+          <a:xfrm>
+            <a:off x="6609631" y="414018"/>
+            <a:ext cx="168339" cy="174795"/>
+          </a:xfrm>
+          <a:prstGeom prst="ellipse">
+            <a:avLst/>
+          </a:prstGeom>
+          <a:solidFill>
+            <a:schemeClr val="bg1"/>
+          </a:solidFill>
+          <a:ln>
+            <a:solidFill>
+              <a:schemeClr val="tx1"/>
+            </a:solidFill>
+          </a:ln>
+        </p:spPr>
+        <p:style>
+          <a:lnRef idx="2">
+            <a:schemeClr val="accent1">
+              <a:shade val="15000"/>
+            </a:schemeClr>
+          </a:lnRef>
+          <a:fillRef idx="1">
+            <a:schemeClr val="accent1"/>
+          </a:fillRef>
+          <a:effectRef idx="0">
+            <a:schemeClr val="accent1"/>
+          </a:effectRef>
+          <a:fontRef idx="minor">
+            <a:schemeClr val="lt1"/>
+          </a:fontRef>
+        </p:style>
+        <p:txBody>
+          <a:bodyPr rtlCol="0" anchor="ctr"/>
+          <a:lstStyle/>
+          <a:p>
+            <a:pPr algn="ctr"/>
+            <a:endParaRPr kumimoji="1" lang="ja-JP" altLang="en-US"/>
+          </a:p>
+        </p:txBody>
+      </p:sp>
+      <p:cxnSp>
+        <p:nvCxnSpPr>
+          <p:cNvPr id="24" name="カギ線コネクタ 23">
+            <a:extLst>
+              <a:ext uri="{FF2B5EF4-FFF2-40B4-BE49-F238E27FC236}">
+                <a16:creationId xmlns:a16="http://schemas.microsoft.com/office/drawing/2014/main" id="{B8A1DCD7-DCFF-AD48-5612-0CC7FB652AE2}"/>
+              </a:ext>
+            </a:extLst>
+          </p:cNvPr>
+          <p:cNvCxnSpPr>
+            <a:cxnSpLocks/>
+            <a:stCxn id="19" idx="6"/>
+            <a:endCxn id="49" idx="0"/>
+          </p:cNvCxnSpPr>
+          <p:nvPr/>
+        </p:nvCxnSpPr>
+        <p:spPr>
+          <a:xfrm>
+            <a:off x="6554316" y="289641"/>
+            <a:ext cx="1550671" cy="644912"/>
+          </a:xfrm>
+          <a:prstGeom prst="bentConnector2">
+            <a:avLst/>
+          </a:prstGeom>
+          <a:ln w="63500">
+            <a:solidFill>
+              <a:srgbClr val="FFC000"/>
+            </a:solidFill>
+            <a:prstDash val="sysDot"/>
+          </a:ln>
+        </p:spPr>
+        <p:style>
+          <a:lnRef idx="2">
+            <a:schemeClr val="accent1"/>
+          </a:lnRef>
+          <a:fillRef idx="0">
+            <a:schemeClr val="accent1"/>
+          </a:fillRef>
+          <a:effectRef idx="1">
+            <a:schemeClr val="accent1"/>
+          </a:effectRef>
+          <a:fontRef idx="minor">
+            <a:schemeClr val="tx1"/>
+          </a:fontRef>
+        </p:style>
+      </p:cxnSp>
+      <p:cxnSp>
+        <p:nvCxnSpPr>
+          <p:cNvPr id="40" name="カギ線コネクタ 39">
+            <a:extLst>
+              <a:ext uri="{FF2B5EF4-FFF2-40B4-BE49-F238E27FC236}">
+                <a16:creationId xmlns:a16="http://schemas.microsoft.com/office/drawing/2014/main" id="{6DC12CC3-C334-1C56-1FB5-BFEFC4BC20A3}"/>
+              </a:ext>
+            </a:extLst>
+          </p:cNvPr>
+          <p:cNvCxnSpPr>
+            <a:cxnSpLocks/>
+            <a:stCxn id="22" idx="6"/>
+            <a:endCxn id="48" idx="0"/>
+          </p:cNvCxnSpPr>
+          <p:nvPr/>
+        </p:nvCxnSpPr>
+        <p:spPr>
+          <a:xfrm>
+            <a:off x="6777970" y="501416"/>
+            <a:ext cx="1103363" cy="684497"/>
+          </a:xfrm>
+          <a:prstGeom prst="bentConnector2">
+            <a:avLst/>
+          </a:prstGeom>
+          <a:ln w="63500">
+            <a:solidFill>
+              <a:schemeClr val="tx1">
+                <a:lumMod val="50000"/>
+                <a:lumOff val="50000"/>
+              </a:schemeClr>
+            </a:solidFill>
+            <a:prstDash val="sysDot"/>
+          </a:ln>
+        </p:spPr>
+        <p:style>
+          <a:lnRef idx="2">
+            <a:schemeClr val="accent1"/>
+          </a:lnRef>
+          <a:fillRef idx="0">
+            <a:schemeClr val="accent1"/>
+          </a:fillRef>
+          <a:effectRef idx="1">
+            <a:schemeClr val="accent1"/>
+          </a:effectRef>
+          <a:fontRef idx="minor">
+            <a:schemeClr val="tx1"/>
+          </a:fontRef>
+        </p:style>
+      </p:cxnSp>
+      <p:sp>
+        <p:nvSpPr>
+          <p:cNvPr id="48" name="円/楕円 47">
+            <a:extLst>
+              <a:ext uri="{FF2B5EF4-FFF2-40B4-BE49-F238E27FC236}">
+                <a16:creationId xmlns:a16="http://schemas.microsoft.com/office/drawing/2014/main" id="{E665B1D0-5EA8-D20F-20F7-B97960EB6B7C}"/>
+              </a:ext>
+            </a:extLst>
+          </p:cNvPr>
+          <p:cNvSpPr/>
+          <p:nvPr/>
+        </p:nvSpPr>
+        <p:spPr>
+          <a:xfrm>
+            <a:off x="7797163" y="1185913"/>
+            <a:ext cx="168339" cy="174795"/>
+          </a:xfrm>
+          <a:prstGeom prst="ellipse">
+            <a:avLst/>
+          </a:prstGeom>
+          <a:solidFill>
+            <a:schemeClr val="bg1"/>
+          </a:solidFill>
+          <a:ln>
+            <a:solidFill>
+              <a:schemeClr val="tx1"/>
+            </a:solidFill>
+          </a:ln>
+        </p:spPr>
+        <p:style>
+          <a:lnRef idx="2">
+            <a:schemeClr val="accent1">
+              <a:shade val="15000"/>
+            </a:schemeClr>
+          </a:lnRef>
+          <a:fillRef idx="1">
+            <a:schemeClr val="accent1"/>
+          </a:fillRef>
+          <a:effectRef idx="0">
+            <a:schemeClr val="accent1"/>
+          </a:effectRef>
+          <a:fontRef idx="minor">
+            <a:schemeClr val="lt1"/>
+          </a:fontRef>
+        </p:style>
+        <p:txBody>
+          <a:bodyPr rtlCol="0" anchor="ctr"/>
+          <a:lstStyle/>
+          <a:p>
+            <a:pPr algn="ctr"/>
+            <a:endParaRPr kumimoji="1" lang="ja-JP" altLang="en-US"/>
+          </a:p>
+        </p:txBody>
+      </p:sp>
+      <p:sp>
+        <p:nvSpPr>
+          <p:cNvPr id="49" name="円/楕円 48">
+            <a:extLst>
+              <a:ext uri="{FF2B5EF4-FFF2-40B4-BE49-F238E27FC236}">
+                <a16:creationId xmlns:a16="http://schemas.microsoft.com/office/drawing/2014/main" id="{663C3100-C2EE-9F6B-54DC-B66373C82ACD}"/>
+              </a:ext>
+            </a:extLst>
+          </p:cNvPr>
+          <p:cNvSpPr/>
+          <p:nvPr/>
+        </p:nvSpPr>
+        <p:spPr>
+          <a:xfrm>
+            <a:off x="8020817" y="934553"/>
+            <a:ext cx="168339" cy="174795"/>
+          </a:xfrm>
+          <a:prstGeom prst="ellipse">
+            <a:avLst/>
+          </a:prstGeom>
+          <a:solidFill>
+            <a:schemeClr val="bg1"/>
+          </a:solidFill>
+          <a:ln>
+            <a:solidFill>
+              <a:schemeClr val="tx1"/>
+            </a:solidFill>
+          </a:ln>
+        </p:spPr>
+        <p:style>
+          <a:lnRef idx="2">
+            <a:schemeClr val="accent1">
+              <a:shade val="15000"/>
+            </a:schemeClr>
+          </a:lnRef>
+          <a:fillRef idx="1">
+            <a:schemeClr val="accent1"/>
+          </a:fillRef>
+          <a:effectRef idx="0">
+            <a:schemeClr val="accent1"/>
+          </a:effectRef>
+          <a:fontRef idx="minor">
+            <a:schemeClr val="lt1"/>
+          </a:fontRef>
+        </p:style>
+        <p:txBody>
+          <a:bodyPr rtlCol="0" anchor="ctr"/>
+          <a:lstStyle/>
+          <a:p>
+            <a:pPr algn="ctr"/>
+            <a:endParaRPr kumimoji="1" lang="ja-JP" altLang="en-US"/>
+          </a:p>
+        </p:txBody>
+      </p:sp>
+      <p:cxnSp>
+        <p:nvCxnSpPr>
+          <p:cNvPr id="54" name="カギ線コネクタ 53">
+            <a:extLst>
+              <a:ext uri="{FF2B5EF4-FFF2-40B4-BE49-F238E27FC236}">
+                <a16:creationId xmlns:a16="http://schemas.microsoft.com/office/drawing/2014/main" id="{3EE0843D-9E9E-5178-A0CA-62A5879E4A79}"/>
+              </a:ext>
+            </a:extLst>
+          </p:cNvPr>
+          <p:cNvCxnSpPr>
+            <a:cxnSpLocks/>
+            <a:stCxn id="59" idx="2"/>
+            <a:endCxn id="48" idx="4"/>
+          </p:cNvCxnSpPr>
+          <p:nvPr/>
+        </p:nvCxnSpPr>
+        <p:spPr>
+          <a:xfrm flipH="1" flipV="1">
+            <a:off x="7881333" y="1360708"/>
+            <a:ext cx="497075" cy="1254836"/>
+          </a:xfrm>
+          <a:prstGeom prst="straightConnector1">
+            <a:avLst/>
+          </a:prstGeom>
+          <a:ln w="63500">
+            <a:solidFill>
+              <a:schemeClr val="tx1">
+                <a:lumMod val="50000"/>
+                <a:lumOff val="50000"/>
+              </a:schemeClr>
+            </a:solidFill>
+            <a:prstDash val="sysDot"/>
+          </a:ln>
+        </p:spPr>
+        <p:style>
+          <a:lnRef idx="2">
+            <a:schemeClr val="accent1"/>
+          </a:lnRef>
+          <a:fillRef idx="0">
+            <a:schemeClr val="accent1"/>
+          </a:fillRef>
+          <a:effectRef idx="1">
+            <a:schemeClr val="accent1"/>
+          </a:effectRef>
+          <a:fontRef idx="minor">
+            <a:schemeClr val="tx1"/>
+          </a:fontRef>
+        </p:style>
+      </p:cxnSp>
+      <p:cxnSp>
+        <p:nvCxnSpPr>
+          <p:cNvPr id="79" name="カギ線コネクタ 78">
+            <a:extLst>
+              <a:ext uri="{FF2B5EF4-FFF2-40B4-BE49-F238E27FC236}">
+                <a16:creationId xmlns:a16="http://schemas.microsoft.com/office/drawing/2014/main" id="{A062C659-2DC0-25AB-C9DF-0C396013118C}"/>
+              </a:ext>
+            </a:extLst>
+          </p:cNvPr>
+          <p:cNvCxnSpPr>
+            <a:cxnSpLocks/>
+            <a:stCxn id="49" idx="4"/>
+            <a:endCxn id="58" idx="2"/>
+          </p:cNvCxnSpPr>
+          <p:nvPr/>
+        </p:nvCxnSpPr>
+        <p:spPr>
+          <a:xfrm>
+            <a:off x="8104987" y="1109348"/>
+            <a:ext cx="281661" cy="1193158"/>
+          </a:xfrm>
+          <a:prstGeom prst="straightConnector1">
+            <a:avLst/>
+          </a:prstGeom>
+          <a:ln w="63500">
+            <a:solidFill>
+              <a:srgbClr val="FFC000"/>
+            </a:solidFill>
+            <a:prstDash val="sysDot"/>
+          </a:ln>
+        </p:spPr>
+        <p:style>
+          <a:lnRef idx="2">
+            <a:schemeClr val="accent1"/>
+          </a:lnRef>
+          <a:fillRef idx="0">
+            <a:schemeClr val="accent1"/>
+          </a:fillRef>
+          <a:effectRef idx="1">
+            <a:schemeClr val="accent1"/>
+          </a:effectRef>
+          <a:fontRef idx="minor">
+            <a:schemeClr val="tx1"/>
+          </a:fontRef>
+        </p:style>
+      </p:cxnSp>
+      <p:grpSp>
+        <p:nvGrpSpPr>
+          <p:cNvPr id="99" name="グループ化 98">
+            <a:extLst>
+              <a:ext uri="{FF2B5EF4-FFF2-40B4-BE49-F238E27FC236}">
+                <a16:creationId xmlns:a16="http://schemas.microsoft.com/office/drawing/2014/main" id="{CBFA37E9-A83E-BD19-D886-FBD6C8A2B32C}"/>
+              </a:ext>
+            </a:extLst>
+          </p:cNvPr>
+          <p:cNvGrpSpPr/>
+          <p:nvPr/>
+        </p:nvGrpSpPr>
+        <p:grpSpPr>
+          <a:xfrm rot="10800000">
+            <a:off x="3228976" y="2169077"/>
+            <a:ext cx="422151" cy="746987"/>
+            <a:chOff x="4618386" y="586941"/>
+            <a:chExt cx="422151" cy="746987"/>
+          </a:xfrm>
+        </p:grpSpPr>
+        <p:sp>
+          <p:nvSpPr>
+            <p:cNvPr id="100" name="正方形/長方形 99">
+              <a:extLst>
+                <a:ext uri="{FF2B5EF4-FFF2-40B4-BE49-F238E27FC236}">
+                  <a16:creationId xmlns:a16="http://schemas.microsoft.com/office/drawing/2014/main" id="{C78E386F-BCD1-77F4-5E10-998F304B3A0A}"/>
+                </a:ext>
+              </a:extLst>
+            </p:cNvPr>
+            <p:cNvSpPr/>
+            <p:nvPr/>
+          </p:nvSpPr>
+          <p:spPr>
+            <a:xfrm>
+              <a:off x="4618386" y="586941"/>
+              <a:ext cx="422151" cy="746987"/>
+            </a:xfrm>
+            <a:prstGeom prst="rect">
+              <a:avLst/>
+            </a:prstGeom>
+          </p:spPr>
+          <p:style>
+            <a:lnRef idx="2">
+              <a:schemeClr val="accent1">
+                <a:shade val="15000"/>
+              </a:schemeClr>
+            </a:lnRef>
+            <a:fillRef idx="1">
+              <a:schemeClr val="accent1"/>
+            </a:fillRef>
+            <a:effectRef idx="0">
+              <a:schemeClr val="accent1"/>
+            </a:effectRef>
+            <a:fontRef idx="minor">
+              <a:schemeClr val="lt1"/>
+            </a:fontRef>
+          </p:style>
+          <p:txBody>
+            <a:bodyPr rtlCol="0" anchor="ctr"/>
+            <a:lstStyle/>
+            <a:p>
+              <a:pPr algn="ctr"/>
+              <a:endParaRPr kumimoji="1" lang="ja-JP" altLang="en-US"/>
+            </a:p>
+          </p:txBody>
+        </p:sp>
+        <p:grpSp>
+          <p:nvGrpSpPr>
+            <p:cNvPr id="103" name="グループ化 102">
+              <a:extLst>
+                <a:ext uri="{FF2B5EF4-FFF2-40B4-BE49-F238E27FC236}">
+                  <a16:creationId xmlns:a16="http://schemas.microsoft.com/office/drawing/2014/main" id="{A276CE52-B0AD-9AEB-DCBB-E4EEC28CBC16}"/>
+                </a:ext>
+              </a:extLst>
+            </p:cNvPr>
+            <p:cNvGrpSpPr/>
+            <p:nvPr/>
+          </p:nvGrpSpPr>
+          <p:grpSpPr>
+            <a:xfrm>
+              <a:off x="4735154" y="680547"/>
+              <a:ext cx="176579" cy="487833"/>
+              <a:chOff x="8159036" y="1423788"/>
+              <a:chExt cx="176579" cy="487833"/>
+            </a:xfrm>
+          </p:grpSpPr>
+          <p:sp>
+            <p:nvSpPr>
+              <p:cNvPr id="104" name="円/楕円 103">
+                <a:extLst>
+                  <a:ext uri="{FF2B5EF4-FFF2-40B4-BE49-F238E27FC236}">
+                    <a16:creationId xmlns:a16="http://schemas.microsoft.com/office/drawing/2014/main" id="{5209DB94-24AA-FBD3-4DE6-949E26B5E764}"/>
+                  </a:ext>
+                </a:extLst>
+              </p:cNvPr>
+              <p:cNvSpPr/>
+              <p:nvPr/>
+            </p:nvSpPr>
+            <p:spPr>
+              <a:xfrm>
+                <a:off x="8167276" y="1423788"/>
+                <a:ext cx="168339" cy="174795"/>
+              </a:xfrm>
+              <a:prstGeom prst="ellipse">
+                <a:avLst/>
+              </a:prstGeom>
+              <a:solidFill>
+                <a:schemeClr val="bg1"/>
+              </a:solidFill>
+              <a:ln>
+                <a:solidFill>
+                  <a:schemeClr val="tx1"/>
+                </a:solidFill>
+              </a:ln>
+            </p:spPr>
+            <p:style>
+              <a:lnRef idx="2">
+                <a:schemeClr val="accent1">
+                  <a:shade val="15000"/>
+                </a:schemeClr>
+              </a:lnRef>
+              <a:fillRef idx="1">
+                <a:schemeClr val="accent1"/>
+              </a:fillRef>
+              <a:effectRef idx="0">
+                <a:schemeClr val="accent1"/>
+              </a:effectRef>
+              <a:fontRef idx="minor">
+                <a:schemeClr val="lt1"/>
+              </a:fontRef>
+            </p:style>
+            <p:txBody>
+              <a:bodyPr rtlCol="0" anchor="ctr"/>
+              <a:lstStyle/>
+              <a:p>
+                <a:pPr algn="ctr"/>
+                <a:endParaRPr kumimoji="1" lang="ja-JP" altLang="en-US"/>
+              </a:p>
+            </p:txBody>
+          </p:sp>
+          <p:sp>
+            <p:nvSpPr>
+              <p:cNvPr id="105" name="円/楕円 104">
+                <a:extLst>
+                  <a:ext uri="{FF2B5EF4-FFF2-40B4-BE49-F238E27FC236}">
+                    <a16:creationId xmlns:a16="http://schemas.microsoft.com/office/drawing/2014/main" id="{4E13CBCC-55E0-765F-0635-94EC610F4597}"/>
+                  </a:ext>
+                </a:extLst>
+              </p:cNvPr>
+              <p:cNvSpPr/>
+              <p:nvPr/>
+            </p:nvSpPr>
+            <p:spPr>
+              <a:xfrm>
+                <a:off x="8159036" y="1736826"/>
+                <a:ext cx="168339" cy="174795"/>
+              </a:xfrm>
+              <a:prstGeom prst="ellipse">
+                <a:avLst/>
+              </a:prstGeom>
+              <a:solidFill>
+                <a:schemeClr val="bg1"/>
+              </a:solidFill>
+              <a:ln>
+                <a:solidFill>
+                  <a:schemeClr val="tx1"/>
+                </a:solidFill>
+              </a:ln>
+            </p:spPr>
+            <p:style>
+              <a:lnRef idx="2">
+                <a:schemeClr val="accent1">
+                  <a:shade val="15000"/>
+                </a:schemeClr>
+              </a:lnRef>
+              <a:fillRef idx="1">
+                <a:schemeClr val="accent1"/>
+              </a:fillRef>
+              <a:effectRef idx="0">
+                <a:schemeClr val="accent1"/>
+              </a:effectRef>
+              <a:fontRef idx="minor">
+                <a:schemeClr val="lt1"/>
+              </a:fontRef>
+            </p:style>
+            <p:txBody>
+              <a:bodyPr rtlCol="0" anchor="ctr"/>
+              <a:lstStyle/>
+              <a:p>
+                <a:pPr algn="ctr"/>
+                <a:endParaRPr kumimoji="1" lang="ja-JP" altLang="en-US"/>
+              </a:p>
+            </p:txBody>
+          </p:sp>
+        </p:grpSp>
+      </p:grpSp>
+      <p:sp>
+        <p:nvSpPr>
+          <p:cNvPr id="106" name="テキスト ボックス 105">
+            <a:extLst>
+              <a:ext uri="{FF2B5EF4-FFF2-40B4-BE49-F238E27FC236}">
+                <a16:creationId xmlns:a16="http://schemas.microsoft.com/office/drawing/2014/main" id="{990952C8-2602-53ED-B6C4-F49ED68FE9DA}"/>
+              </a:ext>
+            </a:extLst>
+          </p:cNvPr>
+          <p:cNvSpPr txBox="1"/>
+          <p:nvPr/>
+        </p:nvSpPr>
+        <p:spPr>
+          <a:xfrm>
+            <a:off x="2414699" y="2269734"/>
+            <a:ext cx="785793" cy="646331"/>
+          </a:xfrm>
+          <a:prstGeom prst="rect">
+            <a:avLst/>
+          </a:prstGeom>
+          <a:noFill/>
+        </p:spPr>
+        <p:txBody>
+          <a:bodyPr wrap="none" rtlCol="0">
+            <a:spAutoFit/>
+          </a:bodyPr>
+          <a:lstStyle/>
+          <a:p>
+            <a:r>
+              <a:rPr kumimoji="1" lang="en-US" altLang="ja-JP" dirty="0"/>
+              <a:t>VBAT</a:t>
+            </a:r>
+          </a:p>
+          <a:p>
+            <a:r>
+              <a:rPr kumimoji="1" lang="en-US" altLang="ja-JP" dirty="0"/>
+              <a:t>GND</a:t>
+            </a:r>
+            <a:endParaRPr kumimoji="1" lang="ja-JP" altLang="en-US"/>
+          </a:p>
+        </p:txBody>
+      </p:sp>
+      <p:cxnSp>
+        <p:nvCxnSpPr>
+          <p:cNvPr id="107" name="カギ線コネクタ 106">
+            <a:extLst>
+              <a:ext uri="{FF2B5EF4-FFF2-40B4-BE49-F238E27FC236}">
+                <a16:creationId xmlns:a16="http://schemas.microsoft.com/office/drawing/2014/main" id="{798933F6-F9DD-1338-5129-C1CEA391A8DD}"/>
+              </a:ext>
+            </a:extLst>
+          </p:cNvPr>
+          <p:cNvCxnSpPr>
+            <a:cxnSpLocks/>
+            <a:stCxn id="105" idx="2"/>
+            <a:endCxn id="28" idx="2"/>
+          </p:cNvCxnSpPr>
+          <p:nvPr/>
+        </p:nvCxnSpPr>
+        <p:spPr>
+          <a:xfrm>
+            <a:off x="3534359" y="2422022"/>
+            <a:ext cx="454578" cy="366459"/>
+          </a:xfrm>
+          <a:prstGeom prst="straightConnector1">
+            <a:avLst/>
+          </a:prstGeom>
+          <a:ln w="63500">
+            <a:solidFill>
+              <a:srgbClr val="FF0000"/>
+            </a:solidFill>
+            <a:prstDash val="sysDot"/>
+          </a:ln>
+        </p:spPr>
+        <p:style>
+          <a:lnRef idx="2">
+            <a:schemeClr val="accent1"/>
+          </a:lnRef>
+          <a:fillRef idx="0">
+            <a:schemeClr val="accent1"/>
+          </a:fillRef>
+          <a:effectRef idx="1">
+            <a:schemeClr val="accent1"/>
+          </a:effectRef>
+          <a:fontRef idx="minor">
+            <a:schemeClr val="tx1"/>
+          </a:fontRef>
+        </p:style>
+      </p:cxnSp>
+      <p:cxnSp>
+        <p:nvCxnSpPr>
+          <p:cNvPr id="120" name="カギ線コネクタ 119">
+            <a:extLst>
+              <a:ext uri="{FF2B5EF4-FFF2-40B4-BE49-F238E27FC236}">
+                <a16:creationId xmlns:a16="http://schemas.microsoft.com/office/drawing/2014/main" id="{35AFE3B7-A421-8319-E408-487EF3BED573}"/>
+              </a:ext>
+            </a:extLst>
+          </p:cNvPr>
+          <p:cNvCxnSpPr>
+            <a:cxnSpLocks/>
+            <a:stCxn id="104" idx="0"/>
+            <a:endCxn id="123" idx="0"/>
+          </p:cNvCxnSpPr>
+          <p:nvPr/>
+        </p:nvCxnSpPr>
+        <p:spPr>
+          <a:xfrm rot="5400000">
+            <a:off x="3162346" y="2975971"/>
+            <a:ext cx="433117" cy="126091"/>
+          </a:xfrm>
+          <a:prstGeom prst="bentConnector3">
+            <a:avLst>
+              <a:gd name="adj1" fmla="val 50000"/>
+            </a:avLst>
+          </a:prstGeom>
+          <a:ln w="63500">
+            <a:solidFill>
+              <a:schemeClr val="tx1">
+                <a:lumMod val="50000"/>
+                <a:lumOff val="50000"/>
+              </a:schemeClr>
+            </a:solidFill>
+            <a:prstDash val="sysDot"/>
+          </a:ln>
+        </p:spPr>
+        <p:style>
+          <a:lnRef idx="2">
+            <a:schemeClr val="accent1"/>
+          </a:lnRef>
+          <a:fillRef idx="0">
+            <a:schemeClr val="accent1"/>
+          </a:fillRef>
+          <a:effectRef idx="1">
+            <a:schemeClr val="accent1"/>
+          </a:effectRef>
+          <a:fontRef idx="minor">
+            <a:schemeClr val="tx1"/>
+          </a:fontRef>
+        </p:style>
+      </p:cxnSp>
+      <p:grpSp>
+        <p:nvGrpSpPr>
+          <p:cNvPr id="125" name="グループ化 124">
+            <a:extLst>
+              <a:ext uri="{FF2B5EF4-FFF2-40B4-BE49-F238E27FC236}">
+                <a16:creationId xmlns:a16="http://schemas.microsoft.com/office/drawing/2014/main" id="{AD714E79-93F7-5203-EEB6-F30B97D0B25F}"/>
+              </a:ext>
+            </a:extLst>
+          </p:cNvPr>
+          <p:cNvGrpSpPr/>
+          <p:nvPr/>
+        </p:nvGrpSpPr>
+        <p:grpSpPr>
+          <a:xfrm>
+            <a:off x="3164016" y="3255575"/>
+            <a:ext cx="211403" cy="384340"/>
+            <a:chOff x="3164016" y="3255575"/>
+            <a:chExt cx="211403" cy="384340"/>
+          </a:xfrm>
+        </p:grpSpPr>
+        <p:sp>
+          <p:nvSpPr>
+            <p:cNvPr id="123" name="正方形/長方形 122">
+              <a:extLst>
+                <a:ext uri="{FF2B5EF4-FFF2-40B4-BE49-F238E27FC236}">
+                  <a16:creationId xmlns:a16="http://schemas.microsoft.com/office/drawing/2014/main" id="{6BBAE06F-522F-85C5-8527-5E627C7E2F2E}"/>
+                </a:ext>
+              </a:extLst>
+            </p:cNvPr>
+            <p:cNvSpPr/>
+            <p:nvPr/>
+          </p:nvSpPr>
+          <p:spPr>
+            <a:xfrm>
+              <a:off x="3256429" y="3255575"/>
+              <a:ext cx="118858" cy="384340"/>
+            </a:xfrm>
+            <a:prstGeom prst="rect">
+              <a:avLst/>
+            </a:prstGeom>
+            <a:ln>
+              <a:noFill/>
+            </a:ln>
+          </p:spPr>
+          <p:style>
+            <a:lnRef idx="2">
+              <a:schemeClr val="accent1">
+                <a:shade val="15000"/>
+              </a:schemeClr>
+            </a:lnRef>
+            <a:fillRef idx="1">
+              <a:schemeClr val="accent1"/>
+            </a:fillRef>
+            <a:effectRef idx="0">
+              <a:schemeClr val="accent1"/>
+            </a:effectRef>
+            <a:fontRef idx="minor">
+              <a:schemeClr val="lt1"/>
+            </a:fontRef>
+          </p:style>
+          <p:txBody>
+            <a:bodyPr rtlCol="0" anchor="ctr"/>
+            <a:lstStyle/>
+            <a:p>
+              <a:pPr algn="ctr"/>
+              <a:endParaRPr kumimoji="1" lang="ja-JP" altLang="en-US"/>
+            </a:p>
+          </p:txBody>
+        </p:sp>
+        <p:sp>
+          <p:nvSpPr>
+            <p:cNvPr id="124" name="正方形/長方形 123">
+              <a:extLst>
+                <a:ext uri="{FF2B5EF4-FFF2-40B4-BE49-F238E27FC236}">
+                  <a16:creationId xmlns:a16="http://schemas.microsoft.com/office/drawing/2014/main" id="{112C5B89-FDE3-C782-0A07-2AEB289A868B}"/>
+                </a:ext>
+              </a:extLst>
+            </p:cNvPr>
+            <p:cNvSpPr/>
+            <p:nvPr/>
+          </p:nvSpPr>
+          <p:spPr>
+            <a:xfrm rot="5400000">
+              <a:off x="3209575" y="3352654"/>
+              <a:ext cx="120286" cy="211403"/>
+            </a:xfrm>
+            <a:prstGeom prst="rect">
+              <a:avLst/>
+            </a:prstGeom>
+            <a:ln>
+              <a:noFill/>
+            </a:ln>
+          </p:spPr>
+          <p:style>
+            <a:lnRef idx="2">
+              <a:schemeClr val="accent1">
+                <a:shade val="15000"/>
+              </a:schemeClr>
+            </a:lnRef>
+            <a:fillRef idx="1">
+              <a:schemeClr val="accent1"/>
+            </a:fillRef>
+            <a:effectRef idx="0">
+              <a:schemeClr val="accent1"/>
+            </a:effectRef>
+            <a:fontRef idx="minor">
+              <a:schemeClr val="lt1"/>
+            </a:fontRef>
+          </p:style>
+          <p:txBody>
+            <a:bodyPr rtlCol="0" anchor="ctr"/>
+            <a:lstStyle/>
+            <a:p>
+              <a:pPr algn="ctr"/>
+              <a:endParaRPr kumimoji="1" lang="ja-JP" altLang="en-US"/>
+            </a:p>
+          </p:txBody>
+        </p:sp>
+      </p:grpSp>
+      <p:cxnSp>
+        <p:nvCxnSpPr>
+          <p:cNvPr id="132" name="カギ線コネクタ 131">
+            <a:extLst>
+              <a:ext uri="{FF2B5EF4-FFF2-40B4-BE49-F238E27FC236}">
+                <a16:creationId xmlns:a16="http://schemas.microsoft.com/office/drawing/2014/main" id="{37CFAEE7-FE86-5732-4DF4-DF08B7A04931}"/>
+              </a:ext>
+            </a:extLst>
+          </p:cNvPr>
+          <p:cNvCxnSpPr>
+            <a:cxnSpLocks/>
+            <a:stCxn id="37" idx="2"/>
+            <a:endCxn id="124" idx="0"/>
+          </p:cNvCxnSpPr>
+          <p:nvPr/>
+        </p:nvCxnSpPr>
+        <p:spPr>
+          <a:xfrm rot="10800000" flipV="1">
+            <a:off x="3375421" y="3405994"/>
+            <a:ext cx="601641" cy="52361"/>
+          </a:xfrm>
+          <a:prstGeom prst="bentConnector3">
+            <a:avLst>
+              <a:gd name="adj1" fmla="val 50000"/>
+            </a:avLst>
+          </a:prstGeom>
+          <a:ln w="63500">
+            <a:solidFill>
+              <a:schemeClr val="tx1">
+                <a:lumMod val="50000"/>
+                <a:lumOff val="50000"/>
+              </a:schemeClr>
+            </a:solidFill>
+            <a:prstDash val="sysDot"/>
+          </a:ln>
+        </p:spPr>
+        <p:style>
+          <a:lnRef idx="2">
+            <a:schemeClr val="accent1"/>
+          </a:lnRef>
+          <a:fillRef idx="0">
+            <a:schemeClr val="accent1"/>
+          </a:fillRef>
+          <a:effectRef idx="1">
+            <a:schemeClr val="accent1"/>
+          </a:effectRef>
+          <a:fontRef idx="minor">
+            <a:schemeClr val="tx1"/>
+          </a:fontRef>
+        </p:style>
+      </p:cxnSp>
+    </p:spTree>
+    <p:extLst>
+      <p:ext uri="{BB962C8B-B14F-4D97-AF65-F5344CB8AC3E}">
+        <p14:creationId xmlns:p14="http://schemas.microsoft.com/office/powerpoint/2010/main" val="4088955109"/>
+      </p:ext>
+    </p:extLst>
+  </p:cSld>
+  <p:clrMapOvr>
+    <a:masterClrMapping/>
+  </p:clrMapOvr>
+</p:sld>
+</file>
+
 <file path=ppt/theme/theme1.xml><?xml version="1.0" encoding="utf-8"?>
 <a:theme xmlns:a="http://schemas.openxmlformats.org/drawingml/2006/main" name="Office テーマ">
   <a:themeElements>

</xml_diff>